<commit_message>
Changes to the presentation
</commit_message>
<xml_diff>
--- a/Deep learning for time-series/Assignment 4/Presentation.pptx
+++ b/Deep learning for time-series/Assignment 4/Presentation.pptx
@@ -277,7 +277,7 @@
           <a:p>
             <a:fld id="{1A886069-5185-423F-843D-C2F3A033B902}" type="datetimeFigureOut">
               <a:rPr lang="en-US" smtClean="0"/>
-              <a:t>10/6/2026</a:t>
+              <a:t>10/7/2026</a:t>
             </a:fld>
             <a:endParaRPr lang="en-US"/>
           </a:p>
@@ -331,7 +331,7 @@
           <a:p>
             <a:fld id="{80580A79-C1F5-4728-9713-FF2EEEBEE14A}" type="slidenum">
               <a:rPr lang="en-US" smtClean="0"/>
-              <a:t>‹nr.›</a:t>
+              <a:t>‹#›</a:t>
             </a:fld>
             <a:endParaRPr lang="en-US"/>
           </a:p>
@@ -476,7 +476,7 @@
           <a:p>
             <a:fld id="{1A886069-5185-423F-843D-C2F3A033B902}" type="datetimeFigureOut">
               <a:rPr lang="en-US" smtClean="0"/>
-              <a:t>10/6/2026</a:t>
+              <a:t>10/7/2026</a:t>
             </a:fld>
             <a:endParaRPr lang="en-US"/>
           </a:p>
@@ -530,7 +530,7 @@
           <a:p>
             <a:fld id="{80580A79-C1F5-4728-9713-FF2EEEBEE14A}" type="slidenum">
               <a:rPr lang="en-US" smtClean="0"/>
-              <a:t>‹nr.›</a:t>
+              <a:t>‹#›</a:t>
             </a:fld>
             <a:endParaRPr lang="en-US"/>
           </a:p>
@@ -685,7 +685,7 @@
           <a:p>
             <a:fld id="{1A886069-5185-423F-843D-C2F3A033B902}" type="datetimeFigureOut">
               <a:rPr lang="en-US" smtClean="0"/>
-              <a:t>10/6/2026</a:t>
+              <a:t>10/7/2026</a:t>
             </a:fld>
             <a:endParaRPr lang="en-US"/>
           </a:p>
@@ -739,7 +739,7 @@
           <a:p>
             <a:fld id="{80580A79-C1F5-4728-9713-FF2EEEBEE14A}" type="slidenum">
               <a:rPr lang="en-US" smtClean="0"/>
-              <a:t>‹nr.›</a:t>
+              <a:t>‹#›</a:t>
             </a:fld>
             <a:endParaRPr lang="en-US"/>
           </a:p>
@@ -884,7 +884,7 @@
           <a:p>
             <a:fld id="{1A886069-5185-423F-843D-C2F3A033B902}" type="datetimeFigureOut">
               <a:rPr lang="en-US" smtClean="0"/>
-              <a:t>10/6/2026</a:t>
+              <a:t>10/7/2026</a:t>
             </a:fld>
             <a:endParaRPr lang="en-US"/>
           </a:p>
@@ -938,7 +938,7 @@
           <a:p>
             <a:fld id="{80580A79-C1F5-4728-9713-FF2EEEBEE14A}" type="slidenum">
               <a:rPr lang="en-US" smtClean="0"/>
-              <a:t>‹nr.›</a:t>
+              <a:t>‹#›</a:t>
             </a:fld>
             <a:endParaRPr lang="en-US"/>
           </a:p>
@@ -1160,7 +1160,7 @@
           <a:p>
             <a:fld id="{1A886069-5185-423F-843D-C2F3A033B902}" type="datetimeFigureOut">
               <a:rPr lang="en-US" smtClean="0"/>
-              <a:t>10/6/2026</a:t>
+              <a:t>10/7/2026</a:t>
             </a:fld>
             <a:endParaRPr lang="en-US"/>
           </a:p>
@@ -1214,7 +1214,7 @@
           <a:p>
             <a:fld id="{80580A79-C1F5-4728-9713-FF2EEEBEE14A}" type="slidenum">
               <a:rPr lang="en-US" smtClean="0"/>
-              <a:t>‹nr.›</a:t>
+              <a:t>‹#›</a:t>
             </a:fld>
             <a:endParaRPr lang="en-US"/>
           </a:p>
@@ -1426,7 +1426,7 @@
           <a:p>
             <a:fld id="{1A886069-5185-423F-843D-C2F3A033B902}" type="datetimeFigureOut">
               <a:rPr lang="en-US" smtClean="0"/>
-              <a:t>10/6/2026</a:t>
+              <a:t>10/7/2026</a:t>
             </a:fld>
             <a:endParaRPr lang="en-US"/>
           </a:p>
@@ -1480,7 +1480,7 @@
           <a:p>
             <a:fld id="{80580A79-C1F5-4728-9713-FF2EEEBEE14A}" type="slidenum">
               <a:rPr lang="en-US" smtClean="0"/>
-              <a:t>‹nr.›</a:t>
+              <a:t>‹#›</a:t>
             </a:fld>
             <a:endParaRPr lang="en-US"/>
           </a:p>
@@ -1839,7 +1839,7 @@
           <a:p>
             <a:fld id="{1A886069-5185-423F-843D-C2F3A033B902}" type="datetimeFigureOut">
               <a:rPr lang="en-US" smtClean="0"/>
-              <a:t>10/6/2026</a:t>
+              <a:t>10/7/2026</a:t>
             </a:fld>
             <a:endParaRPr lang="en-US"/>
           </a:p>
@@ -1893,7 +1893,7 @@
           <a:p>
             <a:fld id="{80580A79-C1F5-4728-9713-FF2EEEBEE14A}" type="slidenum">
               <a:rPr lang="en-US" smtClean="0"/>
-              <a:t>‹nr.›</a:t>
+              <a:t>‹#›</a:t>
             </a:fld>
             <a:endParaRPr lang="en-US"/>
           </a:p>
@@ -1981,7 +1981,7 @@
           <a:p>
             <a:fld id="{1A886069-5185-423F-843D-C2F3A033B902}" type="datetimeFigureOut">
               <a:rPr lang="en-US" smtClean="0"/>
-              <a:t>10/6/2026</a:t>
+              <a:t>10/7/2026</a:t>
             </a:fld>
             <a:endParaRPr lang="en-US"/>
           </a:p>
@@ -2035,7 +2035,7 @@
           <a:p>
             <a:fld id="{80580A79-C1F5-4728-9713-FF2EEEBEE14A}" type="slidenum">
               <a:rPr lang="en-US" smtClean="0"/>
-              <a:t>‹nr.›</a:t>
+              <a:t>‹#›</a:t>
             </a:fld>
             <a:endParaRPr lang="en-US"/>
           </a:p>
@@ -2095,7 +2095,7 @@
           <a:p>
             <a:fld id="{1A886069-5185-423F-843D-C2F3A033B902}" type="datetimeFigureOut">
               <a:rPr lang="en-US" smtClean="0"/>
-              <a:t>10/6/2026</a:t>
+              <a:t>10/7/2026</a:t>
             </a:fld>
             <a:endParaRPr lang="en-US"/>
           </a:p>
@@ -2149,7 +2149,7 @@
           <a:p>
             <a:fld id="{80580A79-C1F5-4728-9713-FF2EEEBEE14A}" type="slidenum">
               <a:rPr lang="en-US" smtClean="0"/>
-              <a:t>‹nr.›</a:t>
+              <a:t>‹#›</a:t>
             </a:fld>
             <a:endParaRPr lang="en-US"/>
           </a:p>
@@ -2407,7 +2407,7 @@
           <a:p>
             <a:fld id="{1A886069-5185-423F-843D-C2F3A033B902}" type="datetimeFigureOut">
               <a:rPr lang="en-US" smtClean="0"/>
-              <a:t>10/6/2026</a:t>
+              <a:t>10/7/2026</a:t>
             </a:fld>
             <a:endParaRPr lang="en-US"/>
           </a:p>
@@ -2461,7 +2461,7 @@
           <a:p>
             <a:fld id="{80580A79-C1F5-4728-9713-FF2EEEBEE14A}" type="slidenum">
               <a:rPr lang="en-US" smtClean="0"/>
-              <a:t>‹nr.›</a:t>
+              <a:t>‹#›</a:t>
             </a:fld>
             <a:endParaRPr lang="en-US"/>
           </a:p>
@@ -2696,7 +2696,7 @@
           <a:p>
             <a:fld id="{1A886069-5185-423F-843D-C2F3A033B902}" type="datetimeFigureOut">
               <a:rPr lang="en-US" smtClean="0"/>
-              <a:t>10/6/2026</a:t>
+              <a:t>10/7/2026</a:t>
             </a:fld>
             <a:endParaRPr lang="en-US"/>
           </a:p>
@@ -2750,7 +2750,7 @@
           <a:p>
             <a:fld id="{80580A79-C1F5-4728-9713-FF2EEEBEE14A}" type="slidenum">
               <a:rPr lang="en-US" smtClean="0"/>
-              <a:t>‹nr.›</a:t>
+              <a:t>‹#›</a:t>
             </a:fld>
             <a:endParaRPr lang="en-US"/>
           </a:p>
@@ -2938,7 +2938,7 @@
           <a:p>
             <a:fld id="{1A886069-5185-423F-843D-C2F3A033B902}" type="datetimeFigureOut">
               <a:rPr lang="en-US" smtClean="0"/>
-              <a:t>10/6/2026</a:t>
+              <a:t>10/7/2026</a:t>
             </a:fld>
             <a:endParaRPr lang="en-US"/>
           </a:p>
@@ -3028,7 +3028,7 @@
           <a:p>
             <a:fld id="{80580A79-C1F5-4728-9713-FF2EEEBEE14A}" type="slidenum">
               <a:rPr lang="en-US" smtClean="0"/>
-              <a:t>‹nr.›</a:t>
+              <a:t>‹#›</a:t>
             </a:fld>
             <a:endParaRPr lang="en-US"/>
           </a:p>
@@ -5689,18 +5689,9 @@
           <a:lstStyle/>
           <a:p>
             <a:r>
-              <a:rPr lang="da-DK" dirty="0" err="1"/>
-              <a:t>Experimental</a:t>
-            </a:r>
-            <a:r>
-              <a:rPr lang="da-DK" dirty="0"/>
-              <a:t> </a:t>
-            </a:r>
-            <a:r>
-              <a:rPr lang="da-DK" dirty="0" err="1"/>
-              <a:t>protocol</a:t>
-            </a:r>
-            <a:endParaRPr lang="da-DK" dirty="0"/>
+              <a:rPr lang="da-DK" dirty="0"/>
+              <a:t>Experimental protocol – pipeline </a:t>
+            </a:r>
           </a:p>
         </p:txBody>
       </p:sp>
@@ -6372,41 +6363,41 @@
 </file>
 
 <file path=customXml/item1.xml><?xml version="1.0" encoding="utf-8"?>
+<TemplafyTemplateConfiguration><![CDATA[{"elementsMetadata":[],"transformationConfigurations":[],"templateName":"blankpresentation","templateDescription":"","enableDocumentContentUpdater":false,"version":"2.0"}]]></TemplafyTemplateConfiguration>
+</file>
+
+<file path=customXml/item2.xml><?xml version="1.0" encoding="utf-8"?>
+<TemplafyFormConfiguration><![CDATA[{"formFields":[],"formDataEntries":[]}]]></TemplafyFormConfiguration>
+</file>
+
+<file path=customXml/item3.xml><?xml version="1.0" encoding="utf-8"?>
+<TemplafySlideFormConfiguration><![CDATA[{"formFields":[],"formDataEntries":[]}]]></TemplafySlideFormConfiguration>
+</file>
+
+<file path=customXml/item4.xml><?xml version="1.0" encoding="utf-8"?>
 <TemplafySlideTemplateConfiguration><![CDATA[{"slideVersion":1,"isValidatorEnabled":false,"isLocked":false,"elementsMetadata":[],"slideId":"1054884848216047618","enableDocumentContentUpdater":false,"version":"2.0"}]]></TemplafySlideTemplateConfiguration>
 </file>
 
-<file path=customXml/item2.xml><?xml version="1.0" encoding="utf-8"?>
-<TemplafySlideFormConfiguration><![CDATA[{"formFields":[],"formDataEntries":[]}]]></TemplafySlideFormConfiguration>
-</file>
-
-<file path=customXml/item3.xml><?xml version="1.0" encoding="utf-8"?>
-<TemplafyFormConfiguration><![CDATA[{"formFields":[],"formDataEntries":[]}]]></TemplafyFormConfiguration>
-</file>
-
-<file path=customXml/item4.xml><?xml version="1.0" encoding="utf-8"?>
-<TemplafyTemplateConfiguration><![CDATA[{"elementsMetadata":[],"transformationConfigurations":[],"templateName":"blankpresentation","templateDescription":"","enableDocumentContentUpdater":false,"version":"2.0"}]]></TemplafyTemplateConfiguration>
-</file>
-
 <file path=customXml/itemProps1.xml><?xml version="1.0" encoding="utf-8"?>
-<ds:datastoreItem xmlns:ds="http://schemas.openxmlformats.org/officeDocument/2006/customXml" ds:itemID="{B69ABF3A-B169-44F9-86AC-4E29FB2A2600}">
+<ds:datastoreItem xmlns:ds="http://schemas.openxmlformats.org/officeDocument/2006/customXml" ds:itemID="{386C9AF7-FC43-4772-BF6D-26FE95C56D62}">
   <ds:schemaRefs/>
 </ds:datastoreItem>
 </file>
 
 <file path=customXml/itemProps2.xml><?xml version="1.0" encoding="utf-8"?>
+<ds:datastoreItem xmlns:ds="http://schemas.openxmlformats.org/officeDocument/2006/customXml" ds:itemID="{C5938109-F486-41EA-929F-D7DF65C5D6B1}">
+  <ds:schemaRefs/>
+</ds:datastoreItem>
+</file>
+
+<file path=customXml/itemProps3.xml><?xml version="1.0" encoding="utf-8"?>
 <ds:datastoreItem xmlns:ds="http://schemas.openxmlformats.org/officeDocument/2006/customXml" ds:itemID="{C60B9EDF-596D-4F67-B5E3-411D55B8E8FC}">
   <ds:schemaRefs/>
 </ds:datastoreItem>
 </file>
 
-<file path=customXml/itemProps3.xml><?xml version="1.0" encoding="utf-8"?>
-<ds:datastoreItem xmlns:ds="http://schemas.openxmlformats.org/officeDocument/2006/customXml" ds:itemID="{C5938109-F486-41EA-929F-D7DF65C5D6B1}">
-  <ds:schemaRefs/>
-</ds:datastoreItem>
-</file>
-
 <file path=customXml/itemProps4.xml><?xml version="1.0" encoding="utf-8"?>
-<ds:datastoreItem xmlns:ds="http://schemas.openxmlformats.org/officeDocument/2006/customXml" ds:itemID="{386C9AF7-FC43-4772-BF6D-26FE95C56D62}">
+<ds:datastoreItem xmlns:ds="http://schemas.openxmlformats.org/officeDocument/2006/customXml" ds:itemID="{B69ABF3A-B169-44F9-86AC-4E29FB2A2600}">
   <ds:schemaRefs/>
 </ds:datastoreItem>
 </file>
</xml_diff>

<commit_message>
Almost done with presentation
</commit_message>
<xml_diff>
--- a/Deep learning for time-series/Assignment 4/Presentation.pptx
+++ b/Deep learning for time-series/Assignment 4/Presentation.pptx
@@ -5,7 +5,7 @@
     <p:sldMasterId id="2147483648" r:id="rId5"/>
   </p:sldMasterIdLst>
   <p:notesMasterIdLst>
-    <p:notesMasterId r:id="rId19"/>
+    <p:notesMasterId r:id="rId22"/>
   </p:notesMasterIdLst>
   <p:sldIdLst>
     <p:sldId id="256" r:id="rId6"/>
@@ -13,6 +13,7 @@
     <p:sldId id="268" r:id="rId8"/>
     <p:sldId id="269" r:id="rId9"/>
     <p:sldId id="270" r:id="rId10"/>
+    <p:sldId id="280" r:id="rId28"/>
     <p:sldId id="275" r:id="rId11"/>
     <p:sldId id="272" r:id="rId12"/>
     <p:sldId id="260" r:id="rId13"/>
@@ -20,12 +21,15 @@
     <p:sldId id="263" r:id="rId15"/>
     <p:sldId id="264" r:id="rId16"/>
     <p:sldId id="265" r:id="rId17"/>
-    <p:sldId id="266" r:id="rId18"/>
+    <p:sldId id="276" r:id="rId18"/>
+    <p:sldId id="279" r:id="rId19"/>
+    <p:sldId id="266" r:id="rId20"/>
+    <p:sldId id="277" r:id="rId21"/>
   </p:sldIdLst>
   <p:sldSz cx="12192000" cy="6858000"/>
   <p:notesSz cx="6858000" cy="9144000"/>
   <p:custDataLst>
-    <p:tags r:id="rId20"/>
+    <p:tags r:id="rId23"/>
   </p:custDataLst>
   <p:defaultTextStyle>
     <a:defPPr>
@@ -215,7 +219,7 @@
           <a:p>
             <a:fld id="{826DB14B-D186-4395-AA45-D206432F77E6}" type="datetimeFigureOut">
               <a:rPr lang="da-DK" smtClean="0"/>
-              <a:t>08-10-2026</a:t>
+              <a:t>11-10-2026</a:t>
             </a:fld>
             <a:endParaRPr lang="da-DK"/>
           </a:p>
@@ -373,7 +377,7 @@
           <a:p>
             <a:fld id="{1640D09C-7D50-4707-B5BE-4BF227698062}" type="slidenum">
               <a:rPr lang="da-DK" smtClean="0"/>
-              <a:t>‹nr.›</a:t>
+              <a:t>‹#›</a:t>
             </a:fld>
             <a:endParaRPr lang="da-DK"/>
           </a:p>
@@ -713,7 +717,7 @@
           <a:p>
             <a:fld id="{1A886069-5185-423F-843D-C2F3A033B902}" type="datetimeFigureOut">
               <a:rPr lang="en-US" smtClean="0"/>
-              <a:t>10/8/2026</a:t>
+              <a:t>10/11/2026</a:t>
             </a:fld>
             <a:endParaRPr lang="en-US"/>
           </a:p>
@@ -767,7 +771,7 @@
           <a:p>
             <a:fld id="{80580A79-C1F5-4728-9713-FF2EEEBEE14A}" type="slidenum">
               <a:rPr lang="en-US" smtClean="0"/>
-              <a:t>‹nr.›</a:t>
+              <a:t>‹#›</a:t>
             </a:fld>
             <a:endParaRPr lang="en-US"/>
           </a:p>
@@ -912,7 +916,7 @@
           <a:p>
             <a:fld id="{1A886069-5185-423F-843D-C2F3A033B902}" type="datetimeFigureOut">
               <a:rPr lang="en-US" smtClean="0"/>
-              <a:t>10/8/2026</a:t>
+              <a:t>10/11/2026</a:t>
             </a:fld>
             <a:endParaRPr lang="en-US"/>
           </a:p>
@@ -966,7 +970,7 @@
           <a:p>
             <a:fld id="{80580A79-C1F5-4728-9713-FF2EEEBEE14A}" type="slidenum">
               <a:rPr lang="en-US" smtClean="0"/>
-              <a:t>‹nr.›</a:t>
+              <a:t>‹#›</a:t>
             </a:fld>
             <a:endParaRPr lang="en-US"/>
           </a:p>
@@ -1121,7 +1125,7 @@
           <a:p>
             <a:fld id="{1A886069-5185-423F-843D-C2F3A033B902}" type="datetimeFigureOut">
               <a:rPr lang="en-US" smtClean="0"/>
-              <a:t>10/8/2026</a:t>
+              <a:t>10/11/2026</a:t>
             </a:fld>
             <a:endParaRPr lang="en-US"/>
           </a:p>
@@ -1175,7 +1179,7 @@
           <a:p>
             <a:fld id="{80580A79-C1F5-4728-9713-FF2EEEBEE14A}" type="slidenum">
               <a:rPr lang="en-US" smtClean="0"/>
-              <a:t>‹nr.›</a:t>
+              <a:t>‹#›</a:t>
             </a:fld>
             <a:endParaRPr lang="en-US"/>
           </a:p>
@@ -1320,7 +1324,7 @@
           <a:p>
             <a:fld id="{1A886069-5185-423F-843D-C2F3A033B902}" type="datetimeFigureOut">
               <a:rPr lang="en-US" smtClean="0"/>
-              <a:t>10/8/2026</a:t>
+              <a:t>10/11/2026</a:t>
             </a:fld>
             <a:endParaRPr lang="en-US"/>
           </a:p>
@@ -1374,7 +1378,7 @@
           <a:p>
             <a:fld id="{80580A79-C1F5-4728-9713-FF2EEEBEE14A}" type="slidenum">
               <a:rPr lang="en-US" smtClean="0"/>
-              <a:t>‹nr.›</a:t>
+              <a:t>‹#›</a:t>
             </a:fld>
             <a:endParaRPr lang="en-US"/>
           </a:p>
@@ -1596,7 +1600,7 @@
           <a:p>
             <a:fld id="{1A886069-5185-423F-843D-C2F3A033B902}" type="datetimeFigureOut">
               <a:rPr lang="en-US" smtClean="0"/>
-              <a:t>10/8/2026</a:t>
+              <a:t>10/11/2026</a:t>
             </a:fld>
             <a:endParaRPr lang="en-US"/>
           </a:p>
@@ -1650,7 +1654,7 @@
           <a:p>
             <a:fld id="{80580A79-C1F5-4728-9713-FF2EEEBEE14A}" type="slidenum">
               <a:rPr lang="en-US" smtClean="0"/>
-              <a:t>‹nr.›</a:t>
+              <a:t>‹#›</a:t>
             </a:fld>
             <a:endParaRPr lang="en-US"/>
           </a:p>
@@ -1862,7 +1866,7 @@
           <a:p>
             <a:fld id="{1A886069-5185-423F-843D-C2F3A033B902}" type="datetimeFigureOut">
               <a:rPr lang="en-US" smtClean="0"/>
-              <a:t>10/8/2026</a:t>
+              <a:t>10/11/2026</a:t>
             </a:fld>
             <a:endParaRPr lang="en-US"/>
           </a:p>
@@ -1916,7 +1920,7 @@
           <a:p>
             <a:fld id="{80580A79-C1F5-4728-9713-FF2EEEBEE14A}" type="slidenum">
               <a:rPr lang="en-US" smtClean="0"/>
-              <a:t>‹nr.›</a:t>
+              <a:t>‹#›</a:t>
             </a:fld>
             <a:endParaRPr lang="en-US"/>
           </a:p>
@@ -2275,7 +2279,7 @@
           <a:p>
             <a:fld id="{1A886069-5185-423F-843D-C2F3A033B902}" type="datetimeFigureOut">
               <a:rPr lang="en-US" smtClean="0"/>
-              <a:t>10/8/2026</a:t>
+              <a:t>10/11/2026</a:t>
             </a:fld>
             <a:endParaRPr lang="en-US"/>
           </a:p>
@@ -2329,7 +2333,7 @@
           <a:p>
             <a:fld id="{80580A79-C1F5-4728-9713-FF2EEEBEE14A}" type="slidenum">
               <a:rPr lang="en-US" smtClean="0"/>
-              <a:t>‹nr.›</a:t>
+              <a:t>‹#›</a:t>
             </a:fld>
             <a:endParaRPr lang="en-US"/>
           </a:p>
@@ -2417,7 +2421,7 @@
           <a:p>
             <a:fld id="{1A886069-5185-423F-843D-C2F3A033B902}" type="datetimeFigureOut">
               <a:rPr lang="en-US" smtClean="0"/>
-              <a:t>10/8/2026</a:t>
+              <a:t>10/11/2026</a:t>
             </a:fld>
             <a:endParaRPr lang="en-US"/>
           </a:p>
@@ -2471,7 +2475,7 @@
           <a:p>
             <a:fld id="{80580A79-C1F5-4728-9713-FF2EEEBEE14A}" type="slidenum">
               <a:rPr lang="en-US" smtClean="0"/>
-              <a:t>‹nr.›</a:t>
+              <a:t>‹#›</a:t>
             </a:fld>
             <a:endParaRPr lang="en-US"/>
           </a:p>
@@ -2531,7 +2535,7 @@
           <a:p>
             <a:fld id="{1A886069-5185-423F-843D-C2F3A033B902}" type="datetimeFigureOut">
               <a:rPr lang="en-US" smtClean="0"/>
-              <a:t>10/8/2026</a:t>
+              <a:t>10/11/2026</a:t>
             </a:fld>
             <a:endParaRPr lang="en-US"/>
           </a:p>
@@ -2585,7 +2589,7 @@
           <a:p>
             <a:fld id="{80580A79-C1F5-4728-9713-FF2EEEBEE14A}" type="slidenum">
               <a:rPr lang="en-US" smtClean="0"/>
-              <a:t>‹nr.›</a:t>
+              <a:t>‹#›</a:t>
             </a:fld>
             <a:endParaRPr lang="en-US"/>
           </a:p>
@@ -2843,7 +2847,7 @@
           <a:p>
             <a:fld id="{1A886069-5185-423F-843D-C2F3A033B902}" type="datetimeFigureOut">
               <a:rPr lang="en-US" smtClean="0"/>
-              <a:t>10/8/2026</a:t>
+              <a:t>10/11/2026</a:t>
             </a:fld>
             <a:endParaRPr lang="en-US"/>
           </a:p>
@@ -2897,7 +2901,7 @@
           <a:p>
             <a:fld id="{80580A79-C1F5-4728-9713-FF2EEEBEE14A}" type="slidenum">
               <a:rPr lang="en-US" smtClean="0"/>
-              <a:t>‹nr.›</a:t>
+              <a:t>‹#›</a:t>
             </a:fld>
             <a:endParaRPr lang="en-US"/>
           </a:p>
@@ -3132,7 +3136,7 @@
           <a:p>
             <a:fld id="{1A886069-5185-423F-843D-C2F3A033B902}" type="datetimeFigureOut">
               <a:rPr lang="en-US" smtClean="0"/>
-              <a:t>10/8/2026</a:t>
+              <a:t>10/11/2026</a:t>
             </a:fld>
             <a:endParaRPr lang="en-US"/>
           </a:p>
@@ -3186,7 +3190,7 @@
           <a:p>
             <a:fld id="{80580A79-C1F5-4728-9713-FF2EEEBEE14A}" type="slidenum">
               <a:rPr lang="en-US" smtClean="0"/>
-              <a:t>‹nr.›</a:t>
+              <a:t>‹#›</a:t>
             </a:fld>
             <a:endParaRPr lang="en-US"/>
           </a:p>
@@ -3374,7 +3378,7 @@
           <a:p>
             <a:fld id="{1A886069-5185-423F-843D-C2F3A033B902}" type="datetimeFigureOut">
               <a:rPr lang="en-US" smtClean="0"/>
-              <a:t>10/8/2026</a:t>
+              <a:t>10/11/2026</a:t>
             </a:fld>
             <a:endParaRPr lang="en-US"/>
           </a:p>
@@ -3464,7 +3468,7 @@
           <a:p>
             <a:fld id="{80580A79-C1F5-4728-9713-FF2EEEBEE14A}" type="slidenum">
               <a:rPr lang="en-US" smtClean="0"/>
-              <a:t>‹nr.›</a:t>
+              <a:t>‹#›</a:t>
             </a:fld>
             <a:endParaRPr lang="en-US"/>
           </a:p>
@@ -3898,20 +3902,21 @@
         </p:nvSpPr>
         <p:spPr/>
         <p:txBody>
-          <a:bodyPr/>
+          <a:bodyPr>
+            <a:normAutofit/>
+          </a:bodyPr>
           <a:lstStyle/>
           <a:p>
             <a:r>
               <a:rPr lang="da-DK" dirty="0"/>
-              <a:t>Part D – </a:t>
-            </a:r>
-            <a:r>
-              <a:rPr lang="da-DK" dirty="0" err="1"/>
-              <a:t>robustness</a:t>
-            </a:r>
-            <a:r>
+              <a:t>Part D</a:t>
+            </a:r>
+            <a:br>
               <a:rPr lang="da-DK" dirty="0"/>
-              <a:t> to sensor dropout</a:t>
+            </a:br>
+            <a:r>
+              <a:rPr lang="da-DK" sz="2000" dirty="0"/>
+              <a:t>Robustness to sensor dropout</a:t>
             </a:r>
           </a:p>
         </p:txBody>
@@ -6965,15 +6970,14 @@
           <a:p>
             <a:r>
               <a:rPr lang="da-DK" dirty="0"/>
-              <a:t>Part E – TS2Vec </a:t>
-            </a:r>
-            <a:r>
-              <a:rPr lang="da-DK" dirty="0" err="1"/>
-              <a:t>masking</a:t>
-            </a:r>
-            <a:r>
+              <a:t>Part E</a:t>
+            </a:r>
+            <a:br>
               <a:rPr lang="da-DK" dirty="0"/>
-              <a:t> ablation</a:t>
+            </a:br>
+            <a:r>
+              <a:rPr lang="da-DK" sz="2000" dirty="0"/>
+              <a:t>TS2Vec masking ablation</a:t>
             </a:r>
           </a:p>
         </p:txBody>
@@ -8071,8 +8075,15 @@
           <a:lstStyle/>
           <a:p>
             <a:r>
-              <a:rPr lang="da-DK" dirty="0"/>
-              <a:t>Part F – TF-C for transfer learning</a:t>
+              <a:rPr lang="en-US" dirty="0"/>
+              <a:t>Part F</a:t>
+            </a:r>
+            <a:br>
+              <a:rPr lang="en-US" dirty="0"/>
+            </a:br>
+            <a:r>
+              <a:rPr lang="en-US" sz="2000" dirty="0"/>
+              <a:t>TF-C for transfer learning</a:t>
             </a:r>
           </a:p>
         </p:txBody>
@@ -8553,6 +8564,365 @@
       </p:grpSpPr>
       <p:sp>
         <p:nvSpPr>
+          <p:cNvPr id="2" name="Title 1"/>
+          <p:cNvSpPr>
+            <a:spLocks noGrp="1"/>
+          </p:cNvSpPr>
+          <p:nvPr>
+            <p:ph type="title"/>
+          </p:nvPr>
+        </p:nvSpPr>
+        <p:spPr/>
+        <p:txBody>
+          <a:bodyPr/>
+          <a:lstStyle/>
+          <a:p>
+            <a:r>
+              <a:rPr lang="en-US" dirty="0"/>
+              <a:t>Part F</a:t>
+            </a:r>
+            <a:br>
+              <a:rPr lang="en-US" dirty="0"/>
+            </a:br>
+            <a:r>
+              <a:rPr lang="en-US" sz="2000" dirty="0"/>
+              <a:t>What the supplied pipeline does</a:t>
+            </a:r>
+          </a:p>
+        </p:txBody>
+      </p:sp>
+      <p:sp>
+        <p:nvSpPr>
+          <p:cNvPr id="3" name="Text Placeholder 2"/>
+          <p:cNvSpPr>
+            <a:spLocks noGrp="1"/>
+          </p:cNvSpPr>
+          <p:nvPr>
+            <p:ph type="body" idx="1"/>
+          </p:nvPr>
+        </p:nvSpPr>
+        <p:spPr/>
+        <p:txBody>
+          <a:bodyPr/>
+          <a:lstStyle/>
+          <a:p>
+            <a:r>
+              <a:t>Transfer and labels</a:t>
+            </a:r>
+          </a:p>
+        </p:txBody>
+      </p:sp>
+      <p:sp>
+        <p:nvSpPr>
+          <p:cNvPr id="4" name="Content Placeholder 3"/>
+          <p:cNvSpPr>
+            <a:spLocks noGrp="1"/>
+          </p:cNvSpPr>
+          <p:nvPr>
+            <p:ph sz="half" idx="2"/>
+          </p:nvPr>
+        </p:nvSpPr>
+        <p:spPr/>
+        <p:txBody>
+          <a:bodyPr/>
+          <a:lstStyle/>
+          <a:p>
+            <a:pPr>
+              <a:spcBef>
+                <a:spcPts val="600"/>
+              </a:spcBef>
+            </a:pPr>
+            <a:r>
+              <a:rPr sz="1600" b="1"/>
+              <a:t>Transferred from FD-A: </a:t>
+            </a:r>
+            <a:r>
+              <a:rPr sz="1600"/>
+              <a:t>all pretrained weights: time and frequency encoders and both projectors. The classifier is new.</a:t>
+            </a:r>
+          </a:p>
+          <a:p>
+            <a:pPr>
+              <a:spcBef>
+                <a:spcPts val="600"/>
+              </a:spcBef>
+            </a:pPr>
+            <a:r>
+              <a:rPr sz="1600" b="1"/>
+              <a:t>FD-B labels: </a:t>
+            </a:r>
+            <a:r>
+              <a:rPr sz="1600"/>
+              <a:t>enter in fine-tuning through cross-entropy on the 60 labelled windows, and select which fine-tuned model is kept.</a:t>
+            </a:r>
+          </a:p>
+          <a:p>
+            <a:pPr>
+              <a:spcBef>
+                <a:spcPts val="600"/>
+              </a:spcBef>
+            </a:pPr>
+            <a:r>
+              <a:rPr sz="1600" b="1"/>
+              <a:t>Encoder: </a:t>
+            </a:r>
+            <a:r>
+              <a:rPr sz="1600"/>
+              <a:t>updated, not frozen. All weights are fine-tuned and the contrastive losses stay in the objective.</a:t>
+            </a:r>
+          </a:p>
+        </p:txBody>
+      </p:sp>
+      <p:sp>
+        <p:nvSpPr>
+          <p:cNvPr id="5" name="Text Placeholder 4"/>
+          <p:cNvSpPr>
+            <a:spLocks noGrp="1"/>
+          </p:cNvSpPr>
+          <p:nvPr>
+            <p:ph type="body" sz="quarter" idx="3"/>
+          </p:nvPr>
+        </p:nvSpPr>
+        <p:spPr/>
+        <p:txBody>
+          <a:bodyPr/>
+          <a:lstStyle/>
+          <a:p>
+            <a:r>
+              <a:t>Released code vs. the paper</a:t>
+            </a:r>
+          </a:p>
+        </p:txBody>
+      </p:sp>
+      <p:sp>
+        <p:nvSpPr>
+          <p:cNvPr id="6" name="Content Placeholder 5"/>
+          <p:cNvSpPr>
+            <a:spLocks noGrp="1"/>
+          </p:cNvSpPr>
+          <p:nvPr>
+            <p:ph sz="quarter" idx="4"/>
+          </p:nvPr>
+        </p:nvSpPr>
+        <p:spPr/>
+        <p:txBody>
+          <a:bodyPr/>
+          <a:lstStyle/>
+          <a:p>
+            <a:pPr>
+              <a:spcBef>
+                <a:spcPts val="600"/>
+              </a:spcBef>
+            </a:pPr>
+            <a:r>
+              <a:rPr sz="1600" b="1" dirty="0"/>
+              <a:t>Subset: </a:t>
+            </a:r>
+            <a:r>
+              <a:rPr sz="1600" dirty="0"/>
+              <a:t>pretraining uses 640 of 8,184 FD-A windows (7.8%), hard-coded in main.py.</a:t>
+            </a:r>
+          </a:p>
+          <a:p>
+            <a:pPr>
+              <a:spcBef>
+                <a:spcPts val="600"/>
+              </a:spcBef>
+            </a:pPr>
+            <a:r>
+              <a:rPr sz="1600" b="1" dirty="0"/>
+              <a:t>Loss: </a:t>
+            </a:r>
+            <a:r>
+              <a:rPr sz="1600" dirty="0"/>
+              <a:t>the consistency loss L_C is computed but not </a:t>
+            </a:r>
+            <a:r>
+              <a:rPr sz="1600" dirty="0" err="1"/>
+              <a:t>optimised</a:t>
+            </a:r>
+            <a:r>
+              <a:rPr sz="1600" dirty="0"/>
+              <a:t>; an extra poly-loss term is added.</a:t>
+            </a:r>
+          </a:p>
+          <a:p>
+            <a:pPr>
+              <a:spcBef>
+                <a:spcPts val="600"/>
+              </a:spcBef>
+            </a:pPr>
+            <a:r>
+              <a:rPr sz="1600" b="1" dirty="0"/>
+              <a:t>Validation: </a:t>
+            </a:r>
+            <a:r>
+              <a:rPr sz="1600" dirty="0"/>
+              <a:t>never loaded. The model is selected on training-batch F1.</a:t>
+            </a:r>
+          </a:p>
+          <a:p>
+            <a:pPr>
+              <a:spcBef>
+                <a:spcPts val="600"/>
+              </a:spcBef>
+            </a:pPr>
+            <a:r>
+              <a:rPr sz="1600" b="1" dirty="0"/>
+              <a:t>Test access: </a:t>
+            </a:r>
+            <a:r>
+              <a:rPr sz="1600" dirty="0"/>
+              <a:t>test set scored after every epoch; the best test epoch is reported (no effect here: constant over 40 epochs).</a:t>
+            </a:r>
+          </a:p>
+        </p:txBody>
+      </p:sp>
+    </p:spTree>
+  </p:cSld>
+  <p:clrMapOvr>
+    <a:masterClrMapping/>
+  </p:clrMapOvr>
+</p:sld>
+</file>
+
+<file path=ppt/slides/slide14.xml><?xml version="1.0" encoding="utf-8"?>
+<p:sld xmlns:a="http://schemas.openxmlformats.org/drawingml/2006/main" xmlns:r="http://schemas.openxmlformats.org/officeDocument/2006/relationships" xmlns:p="http://schemas.openxmlformats.org/presentationml/2006/main">
+  <p:cSld>
+    <p:spTree>
+      <p:nvGrpSpPr>
+        <p:cNvPr id="1" name="">
+          <a:extLst>
+            <a:ext uri="{FF2B5EF4-FFF2-40B4-BE49-F238E27FC236}">
+              <a16:creationId xmlns:a16="http://schemas.microsoft.com/office/drawing/2014/main" id="{34C7BC03-6479-038C-EABD-F683E8A601FE}"/>
+            </a:ext>
+          </a:extLst>
+        </p:cNvPr>
+        <p:cNvGrpSpPr/>
+        <p:nvPr/>
+      </p:nvGrpSpPr>
+      <p:grpSpPr>
+        <a:xfrm>
+          <a:off x="0" y="0"/>
+          <a:ext cx="0" cy="0"/>
+          <a:chOff x="0" y="0"/>
+          <a:chExt cx="0" cy="0"/>
+        </a:xfrm>
+      </p:grpSpPr>
+      <p:sp>
+        <p:nvSpPr>
+          <p:cNvPr id="2" name="Titel 1">
+            <a:extLst>
+              <a:ext uri="{FF2B5EF4-FFF2-40B4-BE49-F238E27FC236}">
+                <a16:creationId xmlns:a16="http://schemas.microsoft.com/office/drawing/2014/main" id="{08566014-5EC4-CB71-0254-29ED2F17D74A}"/>
+              </a:ext>
+            </a:extLst>
+          </p:cNvPr>
+          <p:cNvSpPr>
+            <a:spLocks noGrp="1"/>
+          </p:cNvSpPr>
+          <p:nvPr>
+            <p:ph type="title"/>
+          </p:nvPr>
+        </p:nvSpPr>
+        <p:spPr/>
+        <p:txBody>
+          <a:bodyPr/>
+          <a:lstStyle/>
+          <a:p>
+            <a:r>
+              <a:rPr lang="da-DK" dirty="0"/>
+              <a:t>Limitations</a:t>
+            </a:r>
+          </a:p>
+        </p:txBody>
+      </p:sp>
+      <p:sp>
+        <p:nvSpPr>
+          <p:cNvPr id="3" name="Pladsholder til indhold 2">
+            <a:extLst>
+              <a:ext uri="{FF2B5EF4-FFF2-40B4-BE49-F238E27FC236}">
+                <a16:creationId xmlns:a16="http://schemas.microsoft.com/office/drawing/2014/main" id="{A8A3152E-E1B6-5B6B-60F7-7ACE94252529}"/>
+              </a:ext>
+            </a:extLst>
+          </p:cNvPr>
+          <p:cNvSpPr>
+            <a:spLocks noGrp="1"/>
+          </p:cNvSpPr>
+          <p:nvPr>
+            <p:ph idx="1"/>
+          </p:nvPr>
+        </p:nvSpPr>
+        <p:spPr/>
+        <p:txBody>
+          <a:bodyPr/>
+          <a:lstStyle/>
+          <a:p>
+            <a:r>
+              <a:rPr lang="da-DK" dirty="0"/>
+              <a:t>Only three seeds: small differences in results will likely not be significant.</a:t>
+            </a:r>
+          </a:p>
+          <a:p>
+            <a:r>
+              <a:rPr lang="da-DK" dirty="0"/>
+              <a:t>Datasets differ in size, channels, lengths, classes, and structure so no single characteristic can be identified as the cause of the results.</a:t>
+            </a:r>
+          </a:p>
+          <a:p>
+            <a:r>
+              <a:rPr lang="da-DK" dirty="0"/>
+              <a:t>Only one corruption type and convention were used.</a:t>
+            </a:r>
+          </a:p>
+          <a:p>
+            <a:r>
+              <a:rPr lang="da-DK" dirty="0"/>
+              <a:t>The 10% labels set results on AWR are based on an untuned model.</a:t>
+            </a:r>
+          </a:p>
+          <a:p>
+            <a:r>
+              <a:rPr lang="da-DK"/>
+              <a:t>TF-C was not run with the 2022 library version.</a:t>
+            </a:r>
+            <a:endParaRPr lang="da-DK" dirty="0"/>
+          </a:p>
+        </p:txBody>
+      </p:sp>
+    </p:spTree>
+    <p:extLst>
+      <p:ext uri="{BB962C8B-B14F-4D97-AF65-F5344CB8AC3E}">
+        <p14:creationId xmlns:p14="http://schemas.microsoft.com/office/powerpoint/2010/main" val="1668165094"/>
+      </p:ext>
+    </p:extLst>
+  </p:cSld>
+  <p:clrMapOvr>
+    <a:masterClrMapping/>
+  </p:clrMapOvr>
+  <p:transition/>
+</p:sld>
+</file>
+
+<file path=ppt/slides/slide15.xml><?xml version="1.0" encoding="utf-8"?>
+<p:sld xmlns:a="http://schemas.openxmlformats.org/drawingml/2006/main" xmlns:r="http://schemas.openxmlformats.org/officeDocument/2006/relationships" xmlns:p="http://schemas.openxmlformats.org/presentationml/2006/main">
+  <p:cSld>
+    <p:spTree>
+      <p:nvGrpSpPr>
+        <p:cNvPr id="1" name=""/>
+        <p:cNvGrpSpPr/>
+        <p:nvPr/>
+      </p:nvGrpSpPr>
+      <p:grpSpPr>
+        <a:xfrm>
+          <a:off x="0" y="0"/>
+          <a:ext cx="0" cy="0"/>
+          <a:chOff x="0" y="0"/>
+          <a:chExt cx="0" cy="0"/>
+        </a:xfrm>
+      </p:grpSpPr>
+      <p:sp>
+        <p:nvSpPr>
           <p:cNvPr id="2" name="Titel 1">
             <a:extLst>
               <a:ext uri="{FF2B5EF4-FFF2-40B4-BE49-F238E27FC236}">
@@ -8601,7 +8971,7 @@
           <a:bodyPr/>
           <a:lstStyle/>
           <a:p>
-            <a:endParaRPr lang="da-DK"/>
+            <a:endParaRPr lang="da-DK" dirty="0"/>
           </a:p>
         </p:txBody>
       </p:sp>
@@ -8616,6 +8986,938 @@
     <a:masterClrMapping/>
   </p:clrMapOvr>
   <p:transition/>
+</p:sld>
+</file>
+
+<file path=ppt/slides/slide16.xml><?xml version="1.0" encoding="utf-8"?>
+<p:sld xmlns:a="http://schemas.openxmlformats.org/drawingml/2006/main" xmlns:r="http://schemas.openxmlformats.org/officeDocument/2006/relationships" xmlns:p="http://schemas.openxmlformats.org/presentationml/2006/main">
+  <p:cSld>
+    <p:spTree>
+      <p:nvGrpSpPr>
+        <p:cNvPr id="1" name=""/>
+        <p:cNvGrpSpPr/>
+        <p:nvPr/>
+      </p:nvGrpSpPr>
+      <p:grpSpPr>
+        <a:xfrm>
+          <a:off x="0" y="0"/>
+          <a:ext cx="0" cy="0"/>
+          <a:chOff x="0" y="0"/>
+          <a:chExt cx="0" cy="0"/>
+        </a:xfrm>
+      </p:grpSpPr>
+      <p:sp>
+        <p:nvSpPr>
+          <p:cNvPr id="2" name="Title 1"/>
+          <p:cNvSpPr>
+            <a:spLocks noGrp="1"/>
+          </p:cNvSpPr>
+          <p:nvPr>
+            <p:ph type="title"/>
+          </p:nvPr>
+        </p:nvSpPr>
+        <p:spPr/>
+        <p:txBody>
+          <a:bodyPr/>
+          <a:lstStyle/>
+          <a:p>
+            <a:r>
+              <a:rPr lang="en-US" dirty="0"/>
+              <a:t>Part F</a:t>
+            </a:r>
+            <a:br>
+              <a:rPr lang="en-US" dirty="0"/>
+            </a:br>
+            <a:r>
+              <a:rPr lang="en-US" sz="2000" dirty="0"/>
+              <a:t>Execution record</a:t>
+            </a:r>
+          </a:p>
+        </p:txBody>
+      </p:sp>
+      <p:graphicFrame>
+        <p:nvGraphicFramePr>
+          <p:cNvPr id="10" name="Execution record table"/>
+          <p:cNvGraphicFramePr>
+            <a:graphicFrameLocks noGrp="1"/>
+          </p:cNvGraphicFramePr>
+          <p:nvPr/>
+        </p:nvGraphicFramePr>
+        <p:xfrm>
+          <a:off x="841248" y="1737360"/>
+          <a:ext cx="10515600" cy="3877800"/>
+        </p:xfrm>
+        <a:graphic>
+          <a:graphicData uri="http://schemas.openxmlformats.org/drawingml/2006/table">
+            <a:tbl>
+              <a:tblPr firstRow="1"/>
+              <a:tblGrid>
+                <a:gridCol w="2743200">
+                  <a:extLst>
+                    <a:ext uri="{9D8B030D-6E8A-4147-A177-3AD203B41FA5}">
+                      <a16:colId xmlns:a16="http://schemas.microsoft.com/office/drawing/2014/main" val="20000"/>
+                    </a:ext>
+                  </a:extLst>
+                </a:gridCol>
+                <a:gridCol w="7772400">
+                  <a:extLst>
+                    <a:ext uri="{9D8B030D-6E8A-4147-A177-3AD203B41FA5}">
+                      <a16:colId xmlns:a16="http://schemas.microsoft.com/office/drawing/2014/main" val="20001"/>
+                    </a:ext>
+                  </a:extLst>
+                </a:gridCol>
+              </a:tblGrid>
+              <a:tr h="411480">
+                <a:tc>
+                  <a:txBody>
+                    <a:bodyPr/>
+                    <a:lstStyle/>
+                    <a:p>
+                      <a:pPr algn="l"/>
+                      <a:r>
+                        <a:rPr lang="en-US" sz="1400" b="1" dirty="0"/>
+                        <a:t>Item</a:t>
+                      </a:r>
+                    </a:p>
+                  </a:txBody>
+                  <a:tcPr marL="72000" marR="72000" marT="36000" marB="36000" anchor="ctr">
+                    <a:lnL w="12700">
+                      <a:noFill/>
+                    </a:lnL>
+                    <a:lnR w="12700">
+                      <a:noFill/>
+                    </a:lnR>
+                    <a:lnT w="12700">
+                      <a:noFill/>
+                    </a:lnT>
+                    <a:lnB w="19050">
+                      <a:solidFill>
+                        <a:srgbClr val="7F7F7F"/>
+                      </a:solidFill>
+                    </a:lnB>
+                    <a:noFill/>
+                  </a:tcPr>
+                </a:tc>
+                <a:tc>
+                  <a:txBody>
+                    <a:bodyPr/>
+                    <a:lstStyle/>
+                    <a:p>
+                      <a:pPr algn="l"/>
+                      <a:r>
+                        <a:rPr lang="en-US" sz="1400" b="1" dirty="0"/>
+                        <a:t>Value</a:t>
+                      </a:r>
+                    </a:p>
+                  </a:txBody>
+                  <a:tcPr marL="72000" marR="72000" marT="36000" marB="36000" anchor="ctr">
+                    <a:lnL w="12700">
+                      <a:noFill/>
+                    </a:lnL>
+                    <a:lnR w="12700">
+                      <a:noFill/>
+                    </a:lnR>
+                    <a:lnT w="12700">
+                      <a:noFill/>
+                    </a:lnT>
+                    <a:lnB w="19050">
+                      <a:solidFill>
+                        <a:srgbClr val="7F7F7F"/>
+                      </a:solidFill>
+                    </a:lnB>
+                    <a:noFill/>
+                  </a:tcPr>
+                </a:tc>
+                <a:extLst>
+                  <a:ext uri="{0D108BD9-81ED-4DB2-BD59-A6C34878D82A}">
+                    <a16:rowId xmlns:a16="http://schemas.microsoft.com/office/drawing/2014/main" val="10000"/>
+                  </a:ext>
+                </a:extLst>
+              </a:tr>
+              <a:tr h="411480">
+                <a:tc>
+                  <a:txBody>
+                    <a:bodyPr/>
+                    <a:lstStyle/>
+                    <a:p>
+                      <a:pPr algn="l"/>
+                      <a:r>
+                        <a:rPr lang="en-US" sz="1400" b="1" dirty="0"/>
+                        <a:t>Commands</a:t>
+                      </a:r>
+                    </a:p>
+                  </a:txBody>
+                  <a:tcPr marL="72000" marR="72000" marT="36000" marB="36000" anchor="ctr">
+                    <a:lnL w="12700">
+                      <a:noFill/>
+                    </a:lnL>
+                    <a:lnR w="12700">
+                      <a:noFill/>
+                    </a:lnR>
+                    <a:lnT w="19050" cap="flat" cmpd="sng" algn="ctr">
+                      <a:solidFill>
+                        <a:srgbClr val="7F7F7F"/>
+                      </a:solidFill>
+                      <a:prstDash val="solid"/>
+                      <a:round/>
+                      <a:headEnd type="none" w="med" len="med"/>
+                      <a:tailEnd type="none" w="med" len="med"/>
+                    </a:lnT>
+                    <a:lnB w="12700">
+                      <a:solidFill>
+                        <a:srgbClr val="D9D9D9"/>
+                      </a:solidFill>
+                    </a:lnB>
+                    <a:noFill/>
+                  </a:tcPr>
+                </a:tc>
+                <a:tc>
+                  <a:txBody>
+                    <a:bodyPr/>
+                    <a:lstStyle/>
+                    <a:p>
+                      <a:pPr algn="l"/>
+                      <a:r>
+                        <a:rPr lang="en-US" sz="1400" dirty="0"/>
+                        <a:t>python main.py --training_mode pre_train --pretrain_dataset FD_A --target_dataset FD_B --seed 42, then the same with --training_mode fine_tune_test</a:t>
+                      </a:r>
+                    </a:p>
+                  </a:txBody>
+                  <a:tcPr marL="72000" marR="72000" marT="36000" marB="36000" anchor="ctr">
+                    <a:lnL w="12700">
+                      <a:noFill/>
+                    </a:lnL>
+                    <a:lnR w="12700">
+                      <a:noFill/>
+                    </a:lnR>
+                    <a:lnT w="19050" cap="flat" cmpd="sng" algn="ctr">
+                      <a:solidFill>
+                        <a:srgbClr val="7F7F7F"/>
+                      </a:solidFill>
+                      <a:prstDash val="solid"/>
+                      <a:round/>
+                      <a:headEnd type="none" w="med" len="med"/>
+                      <a:tailEnd type="none" w="med" len="med"/>
+                    </a:lnT>
+                    <a:lnB w="12700">
+                      <a:solidFill>
+                        <a:srgbClr val="D9D9D9"/>
+                      </a:solidFill>
+                    </a:lnB>
+                    <a:noFill/>
+                  </a:tcPr>
+                </a:tc>
+                <a:extLst>
+                  <a:ext uri="{0D108BD9-81ED-4DB2-BD59-A6C34878D82A}">
+                    <a16:rowId xmlns:a16="http://schemas.microsoft.com/office/drawing/2014/main" val="10001"/>
+                  </a:ext>
+                </a:extLst>
+              </a:tr>
+              <a:tr h="411480">
+                <a:tc>
+                  <a:txBody>
+                    <a:bodyPr/>
+                    <a:lstStyle/>
+                    <a:p>
+                      <a:pPr algn="l"/>
+                      <a:r>
+                        <a:rPr lang="en-US" sz="1400" b="1" dirty="0"/>
+                        <a:t>Checkout</a:t>
+                      </a:r>
+                    </a:p>
+                  </a:txBody>
+                  <a:tcPr marL="72000" marR="72000" marT="36000" marB="36000" anchor="ctr">
+                    <a:lnL w="12700">
+                      <a:noFill/>
+                    </a:lnL>
+                    <a:lnR w="12700">
+                      <a:noFill/>
+                    </a:lnR>
+                    <a:lnT w="12700" cap="flat" cmpd="sng" algn="ctr">
+                      <a:solidFill>
+                        <a:srgbClr val="D9D9D9"/>
+                      </a:solidFill>
+                      <a:prstDash val="solid"/>
+                      <a:round/>
+                      <a:headEnd type="none" w="med" len="med"/>
+                      <a:tailEnd type="none" w="med" len="med"/>
+                    </a:lnT>
+                    <a:lnB w="12700">
+                      <a:solidFill>
+                        <a:srgbClr val="D9D9D9"/>
+                      </a:solidFill>
+                    </a:lnB>
+                    <a:noFill/>
+                  </a:tcPr>
+                </a:tc>
+                <a:tc>
+                  <a:txBody>
+                    <a:bodyPr/>
+                    <a:lstStyle/>
+                    <a:p>
+                      <a:pPr algn="l"/>
+                      <a:r>
+                        <a:rPr lang="en-US" sz="1400" dirty="0"/>
+                        <a:t>TF-C commit 9667582, no tracked file modified</a:t>
+                      </a:r>
+                    </a:p>
+                  </a:txBody>
+                  <a:tcPr marL="72000" marR="72000" marT="36000" marB="36000" anchor="ctr">
+                    <a:lnL w="12700">
+                      <a:noFill/>
+                    </a:lnL>
+                    <a:lnR w="12700">
+                      <a:noFill/>
+                    </a:lnR>
+                    <a:lnT w="12700" cap="flat" cmpd="sng" algn="ctr">
+                      <a:solidFill>
+                        <a:srgbClr val="D9D9D9"/>
+                      </a:solidFill>
+                      <a:prstDash val="solid"/>
+                      <a:round/>
+                      <a:headEnd type="none" w="med" len="med"/>
+                      <a:tailEnd type="none" w="med" len="med"/>
+                    </a:lnT>
+                    <a:lnB w="12700">
+                      <a:solidFill>
+                        <a:srgbClr val="D9D9D9"/>
+                      </a:solidFill>
+                    </a:lnB>
+                    <a:noFill/>
+                  </a:tcPr>
+                </a:tc>
+                <a:extLst>
+                  <a:ext uri="{0D108BD9-81ED-4DB2-BD59-A6C34878D82A}">
+                    <a16:rowId xmlns:a16="http://schemas.microsoft.com/office/drawing/2014/main" val="10002"/>
+                  </a:ext>
+                </a:extLst>
+              </a:tr>
+              <a:tr h="411480">
+                <a:tc>
+                  <a:txBody>
+                    <a:bodyPr/>
+                    <a:lstStyle/>
+                    <a:p>
+                      <a:pPr algn="l"/>
+                      <a:r>
+                        <a:rPr lang="en-US" sz="1400" b="1" dirty="0"/>
+                        <a:t>Environment</a:t>
+                      </a:r>
+                    </a:p>
+                  </a:txBody>
+                  <a:tcPr marL="72000" marR="72000" marT="36000" marB="36000" anchor="ctr">
+                    <a:lnL w="12700">
+                      <a:noFill/>
+                    </a:lnL>
+                    <a:lnR w="12700">
+                      <a:noFill/>
+                    </a:lnR>
+                    <a:lnT w="12700" cap="flat" cmpd="sng" algn="ctr">
+                      <a:solidFill>
+                        <a:srgbClr val="D9D9D9"/>
+                      </a:solidFill>
+                      <a:prstDash val="solid"/>
+                      <a:round/>
+                      <a:headEnd type="none" w="med" len="med"/>
+                      <a:tailEnd type="none" w="med" len="med"/>
+                    </a:lnT>
+                    <a:lnB w="12700">
+                      <a:solidFill>
+                        <a:srgbClr val="D9D9D9"/>
+                      </a:solidFill>
+                    </a:lnB>
+                    <a:noFill/>
+                  </a:tcPr>
+                </a:tc>
+                <a:tc>
+                  <a:txBody>
+                    <a:bodyPr/>
+                    <a:lstStyle/>
+                    <a:p>
+                      <a:pPr algn="l"/>
+                      <a:r>
+                        <a:rPr lang="en-US" sz="1400" dirty="0"/>
+                        <a:t>Python 3.13.11, PyTorch 2.11.0 (CUDA 12.8), NumPy 2.4.2, scikit-learn 1.8.0, Windows 11</a:t>
+                      </a:r>
+                    </a:p>
+                  </a:txBody>
+                  <a:tcPr marL="72000" marR="72000" marT="36000" marB="36000" anchor="ctr">
+                    <a:lnL w="12700">
+                      <a:noFill/>
+                    </a:lnL>
+                    <a:lnR w="12700">
+                      <a:noFill/>
+                    </a:lnR>
+                    <a:lnT w="12700" cap="flat" cmpd="sng" algn="ctr">
+                      <a:solidFill>
+                        <a:srgbClr val="D9D9D9"/>
+                      </a:solidFill>
+                      <a:prstDash val="solid"/>
+                      <a:round/>
+                      <a:headEnd type="none" w="med" len="med"/>
+                      <a:tailEnd type="none" w="med" len="med"/>
+                    </a:lnT>
+                    <a:lnB w="12700">
+                      <a:solidFill>
+                        <a:srgbClr val="D9D9D9"/>
+                      </a:solidFill>
+                    </a:lnB>
+                    <a:noFill/>
+                  </a:tcPr>
+                </a:tc>
+                <a:extLst>
+                  <a:ext uri="{0D108BD9-81ED-4DB2-BD59-A6C34878D82A}">
+                    <a16:rowId xmlns:a16="http://schemas.microsoft.com/office/drawing/2014/main" val="167658206"/>
+                  </a:ext>
+                </a:extLst>
+              </a:tr>
+              <a:tr h="411480">
+                <a:tc>
+                  <a:txBody>
+                    <a:bodyPr/>
+                    <a:lstStyle/>
+                    <a:p>
+                      <a:pPr algn="l"/>
+                      <a:r>
+                        <a:rPr lang="en-US" sz="1400" b="1" dirty="0"/>
+                        <a:t>Hardware</a:t>
+                      </a:r>
+                    </a:p>
+                  </a:txBody>
+                  <a:tcPr marL="72000" marR="72000" marT="36000" marB="36000" anchor="ctr">
+                    <a:lnL w="12700">
+                      <a:noFill/>
+                    </a:lnL>
+                    <a:lnR w="12700">
+                      <a:noFill/>
+                    </a:lnR>
+                    <a:lnT w="12700" cap="flat" cmpd="sng" algn="ctr">
+                      <a:solidFill>
+                        <a:srgbClr val="D9D9D9"/>
+                      </a:solidFill>
+                      <a:prstDash val="solid"/>
+                      <a:round/>
+                      <a:headEnd type="none" w="med" len="med"/>
+                      <a:tailEnd type="none" w="med" len="med"/>
+                    </a:lnT>
+                    <a:lnB w="12700">
+                      <a:solidFill>
+                        <a:srgbClr val="D9D9D9"/>
+                      </a:solidFill>
+                    </a:lnB>
+                    <a:noFill/>
+                  </a:tcPr>
+                </a:tc>
+                <a:tc>
+                  <a:txBody>
+                    <a:bodyPr/>
+                    <a:lstStyle/>
+                    <a:p>
+                      <a:pPr algn="l"/>
+                      <a:r>
+                        <a:rPr lang="en-US" sz="1400" dirty="0"/>
+                        <a:t>NVIDIA RTX 4500 Ada Generation</a:t>
+                      </a:r>
+                    </a:p>
+                  </a:txBody>
+                  <a:tcPr marL="72000" marR="72000" marT="36000" marB="36000" anchor="ctr">
+                    <a:lnL w="12700">
+                      <a:noFill/>
+                    </a:lnL>
+                    <a:lnR w="12700">
+                      <a:noFill/>
+                    </a:lnR>
+                    <a:lnT w="12700" cap="flat" cmpd="sng" algn="ctr">
+                      <a:solidFill>
+                        <a:srgbClr val="D9D9D9"/>
+                      </a:solidFill>
+                      <a:prstDash val="solid"/>
+                      <a:round/>
+                      <a:headEnd type="none" w="med" len="med"/>
+                      <a:tailEnd type="none" w="med" len="med"/>
+                    </a:lnT>
+                    <a:lnB w="12700">
+                      <a:solidFill>
+                        <a:srgbClr val="D9D9D9"/>
+                      </a:solidFill>
+                    </a:lnB>
+                    <a:noFill/>
+                  </a:tcPr>
+                </a:tc>
+                <a:extLst>
+                  <a:ext uri="{0D108BD9-81ED-4DB2-BD59-A6C34878D82A}">
+                    <a16:rowId xmlns:a16="http://schemas.microsoft.com/office/drawing/2014/main" val="489073057"/>
+                  </a:ext>
+                </a:extLst>
+              </a:tr>
+              <a:tr h="411480">
+                <a:tc>
+                  <a:txBody>
+                    <a:bodyPr/>
+                    <a:lstStyle/>
+                    <a:p>
+                      <a:pPr algn="l"/>
+                      <a:r>
+                        <a:rPr lang="en-US" sz="1400" b="1" dirty="0"/>
+                        <a:t>Seed</a:t>
+                      </a:r>
+                    </a:p>
+                  </a:txBody>
+                  <a:tcPr marL="72000" marR="72000" marT="36000" marB="36000" anchor="ctr">
+                    <a:lnL w="12700">
+                      <a:noFill/>
+                    </a:lnL>
+                    <a:lnR w="12700">
+                      <a:noFill/>
+                    </a:lnR>
+                    <a:lnT w="12700" cap="flat" cmpd="sng" algn="ctr">
+                      <a:solidFill>
+                        <a:srgbClr val="D9D9D9"/>
+                      </a:solidFill>
+                      <a:prstDash val="solid"/>
+                      <a:round/>
+                      <a:headEnd type="none" w="med" len="med"/>
+                      <a:tailEnd type="none" w="med" len="med"/>
+                    </a:lnT>
+                    <a:lnB w="12700">
+                      <a:solidFill>
+                        <a:srgbClr val="D9D9D9"/>
+                      </a:solidFill>
+                    </a:lnB>
+                    <a:noFill/>
+                  </a:tcPr>
+                </a:tc>
+                <a:tc>
+                  <a:txBody>
+                    <a:bodyPr/>
+                    <a:lstStyle/>
+                    <a:p>
+                      <a:pPr algn="l"/>
+                      <a:r>
+                        <a:rPr lang="en-US" sz="1400" dirty="0"/>
+                        <a:t>42</a:t>
+                      </a:r>
+                    </a:p>
+                  </a:txBody>
+                  <a:tcPr marL="72000" marR="72000" marT="36000" marB="36000" anchor="ctr">
+                    <a:lnL w="12700">
+                      <a:noFill/>
+                    </a:lnL>
+                    <a:lnR w="12700">
+                      <a:noFill/>
+                    </a:lnR>
+                    <a:lnT w="12700" cap="flat" cmpd="sng" algn="ctr">
+                      <a:solidFill>
+                        <a:srgbClr val="D9D9D9"/>
+                      </a:solidFill>
+                      <a:prstDash val="solid"/>
+                      <a:round/>
+                      <a:headEnd type="none" w="med" len="med"/>
+                      <a:tailEnd type="none" w="med" len="med"/>
+                    </a:lnT>
+                    <a:lnB w="12700">
+                      <a:solidFill>
+                        <a:srgbClr val="D9D9D9"/>
+                      </a:solidFill>
+                    </a:lnB>
+                    <a:noFill/>
+                  </a:tcPr>
+                </a:tc>
+                <a:extLst>
+                  <a:ext uri="{0D108BD9-81ED-4DB2-BD59-A6C34878D82A}">
+                    <a16:rowId xmlns:a16="http://schemas.microsoft.com/office/drawing/2014/main" val="4036649278"/>
+                  </a:ext>
+                </a:extLst>
+              </a:tr>
+              <a:tr h="411480">
+                <a:tc>
+                  <a:txBody>
+                    <a:bodyPr/>
+                    <a:lstStyle/>
+                    <a:p>
+                      <a:pPr algn="l"/>
+                      <a:r>
+                        <a:rPr lang="en-US" sz="1400" b="1" dirty="0"/>
+                        <a:t>Data consumed</a:t>
+                      </a:r>
+                    </a:p>
+                  </a:txBody>
+                  <a:tcPr marL="72000" marR="72000" marT="36000" marB="36000" anchor="ctr">
+                    <a:lnL w="12700">
+                      <a:noFill/>
+                    </a:lnL>
+                    <a:lnR w="12700">
+                      <a:noFill/>
+                    </a:lnR>
+                    <a:lnT w="12700" cap="flat" cmpd="sng" algn="ctr">
+                      <a:solidFill>
+                        <a:srgbClr val="D9D9D9"/>
+                      </a:solidFill>
+                      <a:prstDash val="solid"/>
+                      <a:round/>
+                      <a:headEnd type="none" w="med" len="med"/>
+                      <a:tailEnd type="none" w="med" len="med"/>
+                    </a:lnT>
+                    <a:lnB w="12700">
+                      <a:solidFill>
+                        <a:srgbClr val="D9D9D9"/>
+                      </a:solidFill>
+                    </a:lnB>
+                    <a:noFill/>
+                  </a:tcPr>
+                </a:tc>
+                <a:tc>
+                  <a:txBody>
+                    <a:bodyPr/>
+                    <a:lstStyle/>
+                    <a:p>
+                      <a:pPr algn="l"/>
+                      <a:r>
+                        <a:rPr lang="en-US" sz="1400" dirty="0"/>
+                        <a:t>Pretraining: 640 FD-A windows. Fine-tuning: 60 FD-B windows. Testing: 13,559 FD-B windows, after each of 40 epochs</a:t>
+                      </a:r>
+                    </a:p>
+                  </a:txBody>
+                  <a:tcPr marL="72000" marR="72000" marT="36000" marB="36000" anchor="ctr">
+                    <a:lnL w="12700">
+                      <a:noFill/>
+                    </a:lnL>
+                    <a:lnR w="12700">
+                      <a:noFill/>
+                    </a:lnR>
+                    <a:lnT w="12700" cap="flat" cmpd="sng" algn="ctr">
+                      <a:solidFill>
+                        <a:srgbClr val="D9D9D9"/>
+                      </a:solidFill>
+                      <a:prstDash val="solid"/>
+                      <a:round/>
+                      <a:headEnd type="none" w="med" len="med"/>
+                      <a:tailEnd type="none" w="med" len="med"/>
+                    </a:lnT>
+                    <a:lnB w="12700">
+                      <a:solidFill>
+                        <a:srgbClr val="D9D9D9"/>
+                      </a:solidFill>
+                    </a:lnB>
+                    <a:noFill/>
+                  </a:tcPr>
+                </a:tc>
+                <a:extLst>
+                  <a:ext uri="{0D108BD9-81ED-4DB2-BD59-A6C34878D82A}">
+                    <a16:rowId xmlns:a16="http://schemas.microsoft.com/office/drawing/2014/main" val="1199454289"/>
+                  </a:ext>
+                </a:extLst>
+              </a:tr>
+              <a:tr h="411480">
+                <a:tc>
+                  <a:txBody>
+                    <a:bodyPr/>
+                    <a:lstStyle/>
+                    <a:p>
+                      <a:pPr algn="l"/>
+                      <a:r>
+                        <a:rPr lang="en-US" sz="1400" b="1" dirty="0"/>
+                        <a:t>Training time</a:t>
+                      </a:r>
+                    </a:p>
+                  </a:txBody>
+                  <a:tcPr marL="72000" marR="72000" marT="36000" marB="36000" anchor="ctr">
+                    <a:lnL w="12700">
+                      <a:noFill/>
+                    </a:lnL>
+                    <a:lnR w="12700">
+                      <a:noFill/>
+                    </a:lnR>
+                    <a:lnT w="12700" cap="flat" cmpd="sng" algn="ctr">
+                      <a:solidFill>
+                        <a:srgbClr val="D9D9D9"/>
+                      </a:solidFill>
+                      <a:prstDash val="solid"/>
+                      <a:round/>
+                      <a:headEnd type="none" w="med" len="med"/>
+                      <a:tailEnd type="none" w="med" len="med"/>
+                    </a:lnT>
+                    <a:lnB w="12700">
+                      <a:solidFill>
+                        <a:srgbClr val="D9D9D9"/>
+                      </a:solidFill>
+                    </a:lnB>
+                    <a:noFill/>
+                  </a:tcPr>
+                </a:tc>
+                <a:tc>
+                  <a:txBody>
+                    <a:bodyPr/>
+                    <a:lstStyle/>
+                    <a:p>
+                      <a:pPr algn="l"/>
+                      <a:r>
+                        <a:rPr lang="en-US" sz="1400" dirty="0"/>
+                        <a:t>Pretraining 180 s; fine-tuning and testing 249 s</a:t>
+                      </a:r>
+                    </a:p>
+                  </a:txBody>
+                  <a:tcPr marL="72000" marR="72000" marT="36000" marB="36000" anchor="ctr">
+                    <a:lnL w="12700">
+                      <a:noFill/>
+                    </a:lnL>
+                    <a:lnR w="12700">
+                      <a:noFill/>
+                    </a:lnR>
+                    <a:lnT w="12700" cap="flat" cmpd="sng" algn="ctr">
+                      <a:solidFill>
+                        <a:srgbClr val="D9D9D9"/>
+                      </a:solidFill>
+                      <a:prstDash val="solid"/>
+                      <a:round/>
+                      <a:headEnd type="none" w="med" len="med"/>
+                      <a:tailEnd type="none" w="med" len="med"/>
+                    </a:lnT>
+                    <a:lnB w="12700">
+                      <a:solidFill>
+                        <a:srgbClr val="D9D9D9"/>
+                      </a:solidFill>
+                    </a:lnB>
+                    <a:noFill/>
+                  </a:tcPr>
+                </a:tc>
+                <a:extLst>
+                  <a:ext uri="{0D108BD9-81ED-4DB2-BD59-A6C34878D82A}">
+                    <a16:rowId xmlns:a16="http://schemas.microsoft.com/office/drawing/2014/main" val="1311215120"/>
+                  </a:ext>
+                </a:extLst>
+              </a:tr>
+              <a:tr h="411480">
+                <a:tc>
+                  <a:txBody>
+                    <a:bodyPr/>
+                    <a:lstStyle/>
+                    <a:p>
+                      <a:pPr algn="l"/>
+                      <a:r>
+                        <a:rPr lang="en-US" sz="1400" b="1" dirty="0"/>
+                        <a:t>Added outside the checkout</a:t>
+                      </a:r>
+                    </a:p>
+                  </a:txBody>
+                  <a:tcPr marL="72000" marR="72000" marT="36000" marB="36000" anchor="ctr">
+                    <a:lnL w="12700">
+                      <a:noFill/>
+                    </a:lnL>
+                    <a:lnR w="12700">
+                      <a:noFill/>
+                    </a:lnR>
+                    <a:lnT w="12700" cap="flat" cmpd="sng" algn="ctr">
+                      <a:solidFill>
+                        <a:srgbClr val="D9D9D9"/>
+                      </a:solidFill>
+                      <a:prstDash val="solid"/>
+                      <a:round/>
+                      <a:headEnd type="none" w="med" len="med"/>
+                      <a:tailEnd type="none" w="med" len="med"/>
+                    </a:lnT>
+                    <a:lnB w="12700">
+                      <a:solidFill>
+                        <a:srgbClr val="D9D9D9"/>
+                      </a:solidFill>
+                    </a:lnB>
+                    <a:noFill/>
+                  </a:tcPr>
+                </a:tc>
+                <a:tc>
+                  <a:txBody>
+                    <a:bodyPr/>
+                    <a:lstStyle/>
+                    <a:p>
+                      <a:pPr algn="l"/>
+                      <a:r>
+                        <a:rPr lang="en-US" sz="1400" dirty="0"/>
+                        <a:t>np.float alias (removed in NumPy 1.24), directory links to the datasets, --logs_save_dir</a:t>
+                      </a:r>
+                    </a:p>
+                  </a:txBody>
+                  <a:tcPr marL="72000" marR="72000" marT="36000" marB="36000" anchor="ctr">
+                    <a:lnL w="12700">
+                      <a:noFill/>
+                    </a:lnL>
+                    <a:lnR w="12700">
+                      <a:noFill/>
+                    </a:lnR>
+                    <a:lnT w="12700" cap="flat" cmpd="sng" algn="ctr">
+                      <a:solidFill>
+                        <a:srgbClr val="D9D9D9"/>
+                      </a:solidFill>
+                      <a:prstDash val="solid"/>
+                      <a:round/>
+                      <a:headEnd type="none" w="med" len="med"/>
+                      <a:tailEnd type="none" w="med" len="med"/>
+                    </a:lnT>
+                    <a:lnB w="12700">
+                      <a:solidFill>
+                        <a:srgbClr val="D9D9D9"/>
+                      </a:solidFill>
+                    </a:lnB>
+                    <a:noFill/>
+                  </a:tcPr>
+                </a:tc>
+                <a:extLst>
+                  <a:ext uri="{0D108BD9-81ED-4DB2-BD59-A6C34878D82A}">
+                    <a16:rowId xmlns:a16="http://schemas.microsoft.com/office/drawing/2014/main" val="1235446586"/>
+                  </a:ext>
+                </a:extLst>
+              </a:tr>
+            </a:tbl>
+          </a:graphicData>
+        </a:graphic>
+      </p:graphicFrame>
+    </p:spTree>
+  </p:cSld>
+  <p:clrMapOvr>
+    <a:masterClrMapping/>
+  </p:clrMapOvr>
+</p:sld>
+</file>
+
+<file path=ppt/slides/slide17.xml><?xml version="1.0" encoding="utf-8"?>
+<p:sld xmlns:a="http://schemas.openxmlformats.org/drawingml/2006/main" xmlns:p="http://schemas.openxmlformats.org/presentationml/2006/main" xmlns:r="http://schemas.openxmlformats.org/officeDocument/2006/relationships">
+  <p:cSld>
+    <p:spTree>
+      <p:nvGrpSpPr>
+        <p:cNvPr id="1" name=""/>
+        <p:cNvGrpSpPr/>
+        <p:nvPr/>
+      </p:nvGrpSpPr>
+      <p:grpSpPr/>
+      <p:sp>
+        <p:nvSpPr>
+          <p:cNvPr id="2" name="Title 1"/>
+          <p:cNvSpPr>
+            <a:spLocks noGrp="1"/>
+          </p:cNvSpPr>
+          <p:nvPr>
+            <p:ph type="title"/>
+          </p:nvPr>
+        </p:nvSpPr>
+        <p:spPr/>
+        <p:txBody>
+          <a:bodyPr/>
+          <a:lstStyle/>
+          <a:p>
+            <a:r>
+              <a:rPr lang="en-US" dirty="0"/>
+              <a:t>Datasets</a:t>
+            </a:r>
+            <a:br>
+              <a:rPr lang="en-US" dirty="0"/>
+            </a:br>
+            <a:r>
+              <a:rPr lang="en-US" sz="2000" dirty="0"/>
+              <a:t>Example waveforms from the training splits</a:t>
+            </a:r>
+          </a:p>
+        </p:txBody>
+      </p:sp>
+      <p:pic>
+        <p:nvPicPr>
+          <p:cNvPr id="3" name="Waveforms FordA" descr="FordA: three training series per class overlaid"/>
+          <p:cNvPicPr>
+            <a:picLocks noChangeAspect="1"/>
+          </p:cNvPicPr>
+          <p:nvPr/>
+        </p:nvPicPr>
+        <p:blipFill>
+          <a:blip r:embed="rId2"/>
+          <a:stretch>
+            <a:fillRect/>
+          </a:stretch>
+        </p:blipFill>
+        <p:spPr>
+          <a:xfrm>
+            <a:off x="841248" y="1783080"/>
+            <a:ext cx="5120640" cy="2148840"/>
+          </a:xfrm>
+          <a:prstGeom prst="rect">
+            <a:avLst/>
+          </a:prstGeom>
+        </p:spPr>
+      </p:pic>
+      <p:pic>
+        <p:nvPicPr>
+          <p:cNvPr id="4" name="Waveforms AWR" descr="AWR: three training series per class overlaid"/>
+          <p:cNvPicPr>
+            <a:picLocks noChangeAspect="1"/>
+          </p:cNvPicPr>
+          <p:nvPr/>
+        </p:nvPicPr>
+        <p:blipFill>
+          <a:blip r:embed="rId3"/>
+          <a:stretch>
+            <a:fillRect/>
+          </a:stretch>
+        </p:blipFill>
+        <p:spPr>
+          <a:xfrm>
+            <a:off x="6236208" y="1783080"/>
+            <a:ext cx="5120640" cy="2148840"/>
+          </a:xfrm>
+          <a:prstGeom prst="rect">
+            <a:avLst/>
+          </a:prstGeom>
+        </p:spPr>
+      </p:pic>
+      <p:pic>
+        <p:nvPicPr>
+          <p:cNvPr id="5" name="Waveforms Epilepsy" descr="Epilepsy: three training series per class overlaid"/>
+          <p:cNvPicPr>
+            <a:picLocks noChangeAspect="1"/>
+          </p:cNvPicPr>
+          <p:nvPr/>
+        </p:nvPicPr>
+        <p:blipFill>
+          <a:blip r:embed="rId4"/>
+          <a:stretch>
+            <a:fillRect/>
+          </a:stretch>
+        </p:blipFill>
+        <p:spPr>
+          <a:xfrm>
+            <a:off x="841248" y="4069080"/>
+            <a:ext cx="5120640" cy="2148840"/>
+          </a:xfrm>
+          <a:prstGeom prst="rect">
+            <a:avLst/>
+          </a:prstGeom>
+        </p:spPr>
+      </p:pic>
+      <p:pic>
+        <p:nvPicPr>
+          <p:cNvPr id="6" name="Waveforms FD-B" descr="FD-B: three training series per class overlaid"/>
+          <p:cNvPicPr>
+            <a:picLocks noChangeAspect="1"/>
+          </p:cNvPicPr>
+          <p:nvPr/>
+        </p:nvPicPr>
+        <p:blipFill>
+          <a:blip r:embed="rId5"/>
+          <a:stretch>
+            <a:fillRect/>
+          </a:stretch>
+        </p:blipFill>
+        <p:spPr>
+          <a:xfrm>
+            <a:off x="6236208" y="4069080"/>
+            <a:ext cx="5120640" cy="2148840"/>
+          </a:xfrm>
+          <a:prstGeom prst="rect">
+            <a:avLst/>
+          </a:prstGeom>
+        </p:spPr>
+      </p:pic>
+    </p:spTree>
+  </p:cSld>
+  <p:clrMapOvr>
+    <a:masterClrMapping/>
+  </p:clrMapOvr>
 </p:sld>
 </file>
 
@@ -9386,48 +10688,62 @@
           <p:nvPr>
             <p:extLst>
               <p:ext uri="{D42A27DB-BD31-4B8C-83A1-F6EECF244321}">
-                <p14:modId xmlns:p14="http://schemas.microsoft.com/office/powerpoint/2010/main" val="2522970901"/>
+                <p14:modId xmlns:p14="http://schemas.microsoft.com/office/powerpoint/2010/main" val="1025021220"/>
               </p:ext>
             </p:extLst>
           </p:nvPr>
         </p:nvGraphicFramePr>
         <p:xfrm>
           <a:off x="838200" y="1905000"/>
-          <a:ext cx="10515600" cy="3556000"/>
+          <a:ext cx="10515600" cy="3180080"/>
         </p:xfrm>
         <a:graphic>
           <a:graphicData uri="http://schemas.openxmlformats.org/drawingml/2006/table">
             <a:tbl>
               <a:tblPr firstRow="1"/>
               <a:tblGrid>
-                <a:gridCol w="4191000">
+                <a:gridCol w="3291840">
                   <a:extLst>
                     <a:ext uri="{9D8B030D-6E8A-4147-A177-3AD203B41FA5}">
                       <a16:colId xmlns:a16="http://schemas.microsoft.com/office/drawing/2014/main" val="20000"/>
                     </a:ext>
                   </a:extLst>
                 </a:gridCol>
-                <a:gridCol w="3175000">
+                <a:gridCol w="2286000">
                   <a:extLst>
                     <a:ext uri="{9D8B030D-6E8A-4147-A177-3AD203B41FA5}">
                       <a16:colId xmlns:a16="http://schemas.microsoft.com/office/drawing/2014/main" val="20001"/>
                     </a:ext>
                   </a:extLst>
                 </a:gridCol>
-                <a:gridCol w="1574800">
+                <a:gridCol w="1280160">
                   <a:extLst>
                     <a:ext uri="{9D8B030D-6E8A-4147-A177-3AD203B41FA5}">
                       <a16:colId xmlns:a16="http://schemas.microsoft.com/office/drawing/2014/main" val="20002"/>
                     </a:ext>
                   </a:extLst>
                 </a:gridCol>
-                <a:gridCol w="1574800">
+                <a:gridCol w="1188720">
                   <a:extLst>
                     <a:ext uri="{9D8B030D-6E8A-4147-A177-3AD203B41FA5}">
                       <a16:colId xmlns:a16="http://schemas.microsoft.com/office/drawing/2014/main" val="20003"/>
                     </a:ext>
                   </a:extLst>
                 </a:gridCol>
+                <a:gridCol w="1188720">
+                  <a:extLst>
+                    <a:ext uri="{9D8B030D-6E8A-4147-A177-3AD203B41FA5}">
+                      <a16:colId xmlns:a16="http://schemas.microsoft.com/office/drawing/2014/main" val="3378894743"/>
+                    </a:ext>
+                  </a:extLst>
+                </a:gridCol>
+                <a:gridCol w="1280160">
+                  <a:extLst>
+                    <a:ext uri="{9D8B030D-6E8A-4147-A177-3AD203B41FA5}">
+                      <a16:colId xmlns:a16="http://schemas.microsoft.com/office/drawing/2014/main" val="3150365493"/>
+                    </a:ext>
+                  </a:extLst>
+                </a:gridCol>
               </a:tblGrid>
               <a:tr h="508000">
                 <a:tc>
@@ -9531,6 +10847,68 @@
                       <a:r>
                         <a:rPr lang="en-US" sz="1800" b="1" dirty="0"/>
                         <a:t>Classes</a:t>
+                      </a:r>
+                      <a:endParaRPr lang="en-US" sz="1800" dirty="0"/>
+                    </a:p>
+                  </a:txBody>
+                  <a:tcPr anchor="ctr">
+                    <a:lnL w="12700">
+                      <a:noFill/>
+                    </a:lnL>
+                    <a:lnR w="12700">
+                      <a:noFill/>
+                    </a:lnR>
+                    <a:lnT w="12700">
+                      <a:noFill/>
+                    </a:lnT>
+                    <a:lnB w="19050">
+                      <a:solidFill>
+                        <a:srgbClr val="7F7F7F"/>
+                      </a:solidFill>
+                    </a:lnB>
+                    <a:noFill/>
+                  </a:tcPr>
+                </a:tc>
+                <a:tc>
+                  <a:txBody>
+                    <a:bodyPr/>
+                    <a:lstStyle/>
+                    <a:p>
+                      <a:pPr algn="r"/>
+                      <a:r>
+                        <a:rPr lang="en-US" sz="1800" b="1" dirty="0"/>
+                        <a:t>Train</a:t>
+                      </a:r>
+                      <a:endParaRPr lang="en-US" sz="1800" dirty="0"/>
+                    </a:p>
+                  </a:txBody>
+                  <a:tcPr anchor="ctr">
+                    <a:lnL w="12700">
+                      <a:noFill/>
+                    </a:lnL>
+                    <a:lnR w="12700">
+                      <a:noFill/>
+                    </a:lnR>
+                    <a:lnT w="12700">
+                      <a:noFill/>
+                    </a:lnT>
+                    <a:lnB w="19050">
+                      <a:solidFill>
+                        <a:srgbClr val="7F7F7F"/>
+                      </a:solidFill>
+                    </a:lnB>
+                    <a:noFill/>
+                  </a:tcPr>
+                </a:tc>
+                <a:tc>
+                  <a:txBody>
+                    <a:bodyPr/>
+                    <a:lstStyle/>
+                    <a:p>
+                      <a:pPr algn="r"/>
+                      <a:r>
+                        <a:rPr lang="en-US" sz="1800" b="1" dirty="0"/>
+                        <a:t>Test</a:t>
                       </a:r>
                       <a:endParaRPr lang="en-US" sz="1800" dirty="0"/>
                     </a:p>
@@ -9705,6 +11083,78 @@
                     <a:noFill/>
                   </a:tcPr>
                 </a:tc>
+                <a:tc>
+                  <a:txBody>
+                    <a:bodyPr/>
+                    <a:lstStyle/>
+                    <a:p>
+                      <a:pPr algn="r"/>
+                      <a:r>
+                        <a:rPr lang="en-US" sz="1800" dirty="0"/>
+                        <a:t>3,601</a:t>
+                      </a:r>
+                    </a:p>
+                  </a:txBody>
+                  <a:tcPr anchor="ctr">
+                    <a:lnL w="12700">
+                      <a:noFill/>
+                    </a:lnL>
+                    <a:lnR w="12700">
+                      <a:noFill/>
+                    </a:lnR>
+                    <a:lnT w="19050" cap="flat" cmpd="sng" algn="ctr">
+                      <a:solidFill>
+                        <a:srgbClr val="7F7F7F"/>
+                      </a:solidFill>
+                      <a:prstDash val="solid"/>
+                      <a:round/>
+                      <a:headEnd type="none" w="med" len="med"/>
+                      <a:tailEnd type="none" w="med" len="med"/>
+                    </a:lnT>
+                    <a:lnB w="12700">
+                      <a:solidFill>
+                        <a:srgbClr val="D9D9D9"/>
+                      </a:solidFill>
+                    </a:lnB>
+                    <a:noFill/>
+                  </a:tcPr>
+                </a:tc>
+                <a:tc>
+                  <a:txBody>
+                    <a:bodyPr/>
+                    <a:lstStyle/>
+                    <a:p>
+                      <a:pPr algn="r"/>
+                      <a:r>
+                        <a:rPr lang="en-US" sz="1800" dirty="0"/>
+                        <a:t>1,320</a:t>
+                      </a:r>
+                    </a:p>
+                  </a:txBody>
+                  <a:tcPr anchor="ctr">
+                    <a:lnL w="12700">
+                      <a:noFill/>
+                    </a:lnL>
+                    <a:lnR w="12700">
+                      <a:noFill/>
+                    </a:lnR>
+                    <a:lnT w="19050" cap="flat" cmpd="sng" algn="ctr">
+                      <a:solidFill>
+                        <a:srgbClr val="7F7F7F"/>
+                      </a:solidFill>
+                      <a:prstDash val="solid"/>
+                      <a:round/>
+                      <a:headEnd type="none" w="med" len="med"/>
+                      <a:tailEnd type="none" w="med" len="med"/>
+                    </a:lnT>
+                    <a:lnB w="12700">
+                      <a:solidFill>
+                        <a:srgbClr val="D9D9D9"/>
+                      </a:solidFill>
+                    </a:lnB>
+                    <a:noFill/>
+                  </a:tcPr>
+                </a:tc>
                 <a:extLst>
                   <a:ext uri="{0D108BD9-81ED-4DB2-BD59-A6C34878D82A}">
                     <a16:rowId xmlns:a16="http://schemas.microsoft.com/office/drawing/2014/main" val="10001"/>
@@ -9720,158 +11170,6 @@
                       <a:pPr algn="l"/>
                       <a:r>
                         <a:rPr lang="en-US" sz="1800" b="1" dirty="0"/>
-                        <a:t>FordB</a:t>
-                      </a:r>
-                      <a:endParaRPr lang="en-US" sz="1800" dirty="0"/>
-                    </a:p>
-                  </a:txBody>
-                  <a:tcPr anchor="ctr">
-                    <a:lnL w="12700">
-                      <a:noFill/>
-                    </a:lnL>
-                    <a:lnR w="12700">
-                      <a:noFill/>
-                    </a:lnR>
-                    <a:lnT w="12700" cap="flat" cmpd="sng" algn="ctr">
-                      <a:solidFill>
-                        <a:srgbClr val="D9D9D9"/>
-                      </a:solidFill>
-                      <a:prstDash val="solid"/>
-                      <a:round/>
-                      <a:headEnd type="none" w="med" len="med"/>
-                      <a:tailEnd type="none" w="med" len="med"/>
-                    </a:lnT>
-                    <a:lnB w="12700">
-                      <a:solidFill>
-                        <a:srgbClr val="D9D9D9"/>
-                      </a:solidFill>
-                    </a:lnB>
-                    <a:noFill/>
-                  </a:tcPr>
-                </a:tc>
-                <a:tc>
-                  <a:txBody>
-                    <a:bodyPr/>
-                    <a:lstStyle/>
-                    <a:p>
-                      <a:pPr algn="l"/>
-                      <a:r>
-                        <a:rPr lang="en-US" sz="1800" dirty="0"/>
-                        <a:t>Engine noise</a:t>
-                      </a:r>
-                    </a:p>
-                  </a:txBody>
-                  <a:tcPr anchor="ctr">
-                    <a:lnL w="12700">
-                      <a:noFill/>
-                    </a:lnL>
-                    <a:lnR w="12700">
-                      <a:noFill/>
-                    </a:lnR>
-                    <a:lnT w="12700" cap="flat" cmpd="sng" algn="ctr">
-                      <a:solidFill>
-                        <a:srgbClr val="D9D9D9"/>
-                      </a:solidFill>
-                      <a:prstDash val="solid"/>
-                      <a:round/>
-                      <a:headEnd type="none" w="med" len="med"/>
-                      <a:tailEnd type="none" w="med" len="med"/>
-                    </a:lnT>
-                    <a:lnB w="12700">
-                      <a:solidFill>
-                        <a:srgbClr val="D9D9D9"/>
-                      </a:solidFill>
-                    </a:lnB>
-                    <a:noFill/>
-                  </a:tcPr>
-                </a:tc>
-                <a:tc>
-                  <a:txBody>
-                    <a:bodyPr/>
-                    <a:lstStyle/>
-                    <a:p>
-                      <a:pPr algn="r"/>
-                      <a:r>
-                        <a:rPr lang="en-US" sz="1800" dirty="0"/>
-                        <a:t>1</a:t>
-                      </a:r>
-                    </a:p>
-                  </a:txBody>
-                  <a:tcPr anchor="ctr">
-                    <a:lnL w="12700">
-                      <a:noFill/>
-                    </a:lnL>
-                    <a:lnR w="12700">
-                      <a:noFill/>
-                    </a:lnR>
-                    <a:lnT w="12700" cap="flat" cmpd="sng" algn="ctr">
-                      <a:solidFill>
-                        <a:srgbClr val="D9D9D9"/>
-                      </a:solidFill>
-                      <a:prstDash val="solid"/>
-                      <a:round/>
-                      <a:headEnd type="none" w="med" len="med"/>
-                      <a:tailEnd type="none" w="med" len="med"/>
-                    </a:lnT>
-                    <a:lnB w="12700">
-                      <a:solidFill>
-                        <a:srgbClr val="D9D9D9"/>
-                      </a:solidFill>
-                    </a:lnB>
-                    <a:noFill/>
-                  </a:tcPr>
-                </a:tc>
-                <a:tc>
-                  <a:txBody>
-                    <a:bodyPr/>
-                    <a:lstStyle/>
-                    <a:p>
-                      <a:pPr algn="r"/>
-                      <a:r>
-                        <a:rPr lang="en-US" sz="1800" dirty="0"/>
-                        <a:t>2</a:t>
-                      </a:r>
-                    </a:p>
-                  </a:txBody>
-                  <a:tcPr anchor="ctr">
-                    <a:lnL w="12700">
-                      <a:noFill/>
-                    </a:lnL>
-                    <a:lnR w="12700">
-                      <a:noFill/>
-                    </a:lnR>
-                    <a:lnT w="12700" cap="flat" cmpd="sng" algn="ctr">
-                      <a:solidFill>
-                        <a:srgbClr val="D9D9D9"/>
-                      </a:solidFill>
-                      <a:prstDash val="solid"/>
-                      <a:round/>
-                      <a:headEnd type="none" w="med" len="med"/>
-                      <a:tailEnd type="none" w="med" len="med"/>
-                    </a:lnT>
-                    <a:lnB w="12700">
-                      <a:solidFill>
-                        <a:srgbClr val="D9D9D9"/>
-                      </a:solidFill>
-                    </a:lnB>
-                    <a:noFill/>
-                  </a:tcPr>
-                </a:tc>
-                <a:extLst>
-                  <a:ext uri="{0D108BD9-81ED-4DB2-BD59-A6C34878D82A}">
-                    <a16:rowId xmlns:a16="http://schemas.microsoft.com/office/drawing/2014/main" val="10002"/>
-                  </a:ext>
-                </a:extLst>
-              </a:tr>
-              <a:tr h="508000">
-                <a:tc>
-                  <a:txBody>
-                    <a:bodyPr/>
-                    <a:lstStyle/>
-                    <a:p>
-                      <a:pPr algn="l"/>
-                      <a:r>
-                        <a:rPr lang="en-US" sz="1800" b="1" dirty="0"/>
                         <a:t>Articulary Word Recognition (AWR)</a:t>
                       </a:r>
                       <a:endParaRPr lang="en-US" sz="1800" dirty="0"/>
@@ -9982,6 +11280,78 @@
                       <a:r>
                         <a:rPr lang="en-US" sz="1800" dirty="0"/>
                         <a:t>25</a:t>
+                      </a:r>
+                    </a:p>
+                  </a:txBody>
+                  <a:tcPr anchor="ctr">
+                    <a:lnL w="12700">
+                      <a:noFill/>
+                    </a:lnL>
+                    <a:lnR w="12700">
+                      <a:noFill/>
+                    </a:lnR>
+                    <a:lnT w="12700" cap="flat" cmpd="sng" algn="ctr">
+                      <a:solidFill>
+                        <a:srgbClr val="D9D9D9"/>
+                      </a:solidFill>
+                      <a:prstDash val="solid"/>
+                      <a:round/>
+                      <a:headEnd type="none" w="med" len="med"/>
+                      <a:tailEnd type="none" w="med" len="med"/>
+                    </a:lnT>
+                    <a:lnB w="12700">
+                      <a:solidFill>
+                        <a:srgbClr val="D9D9D9"/>
+                      </a:solidFill>
+                    </a:lnB>
+                    <a:noFill/>
+                  </a:tcPr>
+                </a:tc>
+                <a:tc>
+                  <a:txBody>
+                    <a:bodyPr/>
+                    <a:lstStyle/>
+                    <a:p>
+                      <a:pPr algn="r"/>
+                      <a:r>
+                        <a:rPr lang="en-US" sz="1800" dirty="0"/>
+                        <a:t>275</a:t>
+                      </a:r>
+                    </a:p>
+                  </a:txBody>
+                  <a:tcPr anchor="ctr">
+                    <a:lnL w="12700">
+                      <a:noFill/>
+                    </a:lnL>
+                    <a:lnR w="12700">
+                      <a:noFill/>
+                    </a:lnR>
+                    <a:lnT w="12700" cap="flat" cmpd="sng" algn="ctr">
+                      <a:solidFill>
+                        <a:srgbClr val="D9D9D9"/>
+                      </a:solidFill>
+                      <a:prstDash val="solid"/>
+                      <a:round/>
+                      <a:headEnd type="none" w="med" len="med"/>
+                      <a:tailEnd type="none" w="med" len="med"/>
+                    </a:lnT>
+                    <a:lnB w="12700">
+                      <a:solidFill>
+                        <a:srgbClr val="D9D9D9"/>
+                      </a:solidFill>
+                    </a:lnB>
+                    <a:noFill/>
+                  </a:tcPr>
+                </a:tc>
+                <a:tc>
+                  <a:txBody>
+                    <a:bodyPr/>
+                    <a:lstStyle/>
+                    <a:p>
+                      <a:pPr algn="r"/>
+                      <a:r>
+                        <a:rPr lang="en-US" sz="1800" dirty="0"/>
+                        <a:t>300</a:t>
                       </a:r>
                     </a:p>
                   </a:txBody>
@@ -10161,6 +11531,78 @@
                     <a:noFill/>
                   </a:tcPr>
                 </a:tc>
+                <a:tc>
+                  <a:txBody>
+                    <a:bodyPr/>
+                    <a:lstStyle/>
+                    <a:p>
+                      <a:pPr algn="r"/>
+                      <a:r>
+                        <a:rPr lang="en-US" sz="1800" dirty="0"/>
+                        <a:t>137</a:t>
+                      </a:r>
+                    </a:p>
+                  </a:txBody>
+                  <a:tcPr anchor="ctr">
+                    <a:lnL w="12700">
+                      <a:noFill/>
+                    </a:lnL>
+                    <a:lnR w="12700">
+                      <a:noFill/>
+                    </a:lnR>
+                    <a:lnT w="12700" cap="flat" cmpd="sng" algn="ctr">
+                      <a:solidFill>
+                        <a:srgbClr val="D9D9D9"/>
+                      </a:solidFill>
+                      <a:prstDash val="solid"/>
+                      <a:round/>
+                      <a:headEnd type="none" w="med" len="med"/>
+                      <a:tailEnd type="none" w="med" len="med"/>
+                    </a:lnT>
+                    <a:lnB w="12700">
+                      <a:solidFill>
+                        <a:srgbClr val="D9D9D9"/>
+                      </a:solidFill>
+                    </a:lnB>
+                    <a:noFill/>
+                  </a:tcPr>
+                </a:tc>
+                <a:tc>
+                  <a:txBody>
+                    <a:bodyPr/>
+                    <a:lstStyle/>
+                    <a:p>
+                      <a:pPr algn="r"/>
+                      <a:r>
+                        <a:rPr lang="en-US" sz="1800" dirty="0"/>
+                        <a:t>138</a:t>
+                      </a:r>
+                    </a:p>
+                  </a:txBody>
+                  <a:tcPr anchor="ctr">
+                    <a:lnL w="12700">
+                      <a:noFill/>
+                    </a:lnL>
+                    <a:lnR w="12700">
+                      <a:noFill/>
+                    </a:lnR>
+                    <a:lnT w="12700" cap="flat" cmpd="sng" algn="ctr">
+                      <a:solidFill>
+                        <a:srgbClr val="D9D9D9"/>
+                      </a:solidFill>
+                      <a:prstDash val="solid"/>
+                      <a:round/>
+                      <a:headEnd type="none" w="med" len="med"/>
+                      <a:tailEnd type="none" w="med" len="med"/>
+                    </a:lnT>
+                    <a:lnB w="12700">
+                      <a:solidFill>
+                        <a:srgbClr val="D9D9D9"/>
+                      </a:solidFill>
+                    </a:lnB>
+                    <a:noFill/>
+                  </a:tcPr>
+                </a:tc>
                 <a:extLst>
                   <a:ext uri="{0D108BD9-81ED-4DB2-BD59-A6C34878D82A}">
                     <a16:rowId xmlns:a16="http://schemas.microsoft.com/office/drawing/2014/main" val="10004"/>
@@ -10313,6 +11755,78 @@
                     <a:noFill/>
                   </a:tcPr>
                 </a:tc>
+                <a:tc>
+                  <a:txBody>
+                    <a:bodyPr/>
+                    <a:lstStyle/>
+                    <a:p>
+                      <a:pPr algn="r"/>
+                      <a:r>
+                        <a:rPr lang="en-US" sz="1800" dirty="0"/>
+                        <a:t>8,184</a:t>
+                      </a:r>
+                    </a:p>
+                  </a:txBody>
+                  <a:tcPr anchor="ctr">
+                    <a:lnL w="12700">
+                      <a:noFill/>
+                    </a:lnL>
+                    <a:lnR w="12700">
+                      <a:noFill/>
+                    </a:lnR>
+                    <a:lnT w="12700" cap="flat" cmpd="sng" algn="ctr">
+                      <a:solidFill>
+                        <a:srgbClr val="D9D9D9"/>
+                      </a:solidFill>
+                      <a:prstDash val="solid"/>
+                      <a:round/>
+                      <a:headEnd type="none" w="med" len="med"/>
+                      <a:tailEnd type="none" w="med" len="med"/>
+                    </a:lnT>
+                    <a:lnB w="12700">
+                      <a:solidFill>
+                        <a:srgbClr val="D9D9D9"/>
+                      </a:solidFill>
+                    </a:lnB>
+                    <a:noFill/>
+                  </a:tcPr>
+                </a:tc>
+                <a:tc>
+                  <a:txBody>
+                    <a:bodyPr/>
+                    <a:lstStyle/>
+                    <a:p>
+                      <a:pPr algn="r"/>
+                      <a:r>
+                        <a:rPr lang="en-US" sz="1800" dirty="0"/>
+                        <a:t>2,728</a:t>
+                      </a:r>
+                    </a:p>
+                  </a:txBody>
+                  <a:tcPr anchor="ctr">
+                    <a:lnL w="12700">
+                      <a:noFill/>
+                    </a:lnL>
+                    <a:lnR w="12700">
+                      <a:noFill/>
+                    </a:lnR>
+                    <a:lnT w="12700" cap="flat" cmpd="sng" algn="ctr">
+                      <a:solidFill>
+                        <a:srgbClr val="D9D9D9"/>
+                      </a:solidFill>
+                      <a:prstDash val="solid"/>
+                      <a:round/>
+                      <a:headEnd type="none" w="med" len="med"/>
+                      <a:tailEnd type="none" w="med" len="med"/>
+                    </a:lnT>
+                    <a:lnB w="12700">
+                      <a:solidFill>
+                        <a:srgbClr val="D9D9D9"/>
+                      </a:solidFill>
+                    </a:lnB>
+                    <a:noFill/>
+                  </a:tcPr>
+                </a:tc>
                 <a:extLst>
                   <a:ext uri="{0D108BD9-81ED-4DB2-BD59-A6C34878D82A}">
                     <a16:rowId xmlns:a16="http://schemas.microsoft.com/office/drawing/2014/main" val="10005"/>
@@ -10438,6 +11952,78 @@
                       <a:r>
                         <a:rPr lang="en-US" sz="1800" dirty="0"/>
                         <a:t>3</a:t>
+                      </a:r>
+                    </a:p>
+                  </a:txBody>
+                  <a:tcPr anchor="ctr">
+                    <a:lnL w="12700">
+                      <a:noFill/>
+                    </a:lnL>
+                    <a:lnR w="12700">
+                      <a:noFill/>
+                    </a:lnR>
+                    <a:lnT w="12700" cap="flat" cmpd="sng" algn="ctr">
+                      <a:solidFill>
+                        <a:srgbClr val="D9D9D9"/>
+                      </a:solidFill>
+                      <a:prstDash val="solid"/>
+                      <a:round/>
+                      <a:headEnd type="none" w="med" len="med"/>
+                      <a:tailEnd type="none" w="med" len="med"/>
+                    </a:lnT>
+                    <a:lnB w="12700">
+                      <a:solidFill>
+                        <a:srgbClr val="D9D9D9"/>
+                      </a:solidFill>
+                    </a:lnB>
+                    <a:noFill/>
+                  </a:tcPr>
+                </a:tc>
+                <a:tc>
+                  <a:txBody>
+                    <a:bodyPr/>
+                    <a:lstStyle/>
+                    <a:p>
+                      <a:pPr algn="r"/>
+                      <a:r>
+                        <a:rPr lang="en-US" sz="1800" dirty="0"/>
+                        <a:t>60</a:t>
+                      </a:r>
+                    </a:p>
+                  </a:txBody>
+                  <a:tcPr anchor="ctr">
+                    <a:lnL w="12700">
+                      <a:noFill/>
+                    </a:lnL>
+                    <a:lnR w="12700">
+                      <a:noFill/>
+                    </a:lnR>
+                    <a:lnT w="12700" cap="flat" cmpd="sng" algn="ctr">
+                      <a:solidFill>
+                        <a:srgbClr val="D9D9D9"/>
+                      </a:solidFill>
+                      <a:prstDash val="solid"/>
+                      <a:round/>
+                      <a:headEnd type="none" w="med" len="med"/>
+                      <a:tailEnd type="none" w="med" len="med"/>
+                    </a:lnT>
+                    <a:lnB w="12700">
+                      <a:solidFill>
+                        <a:srgbClr val="D9D9D9"/>
+                      </a:solidFill>
+                    </a:lnB>
+                    <a:noFill/>
+                  </a:tcPr>
+                </a:tc>
+                <a:tc>
+                  <a:txBody>
+                    <a:bodyPr/>
+                    <a:lstStyle/>
+                    <a:p>
+                      <a:pPr algn="r"/>
+                      <a:r>
+                        <a:rPr lang="en-US" sz="1800" dirty="0"/>
+                        <a:t>13,559</a:t>
                       </a:r>
                     </a:p>
                   </a:txBody>
@@ -10475,6 +12061,35 @@
           </a:graphicData>
         </a:graphic>
       </p:graphicFrame>
+      <p:sp>
+        <p:nvSpPr>
+          <p:cNvPr id="5" name="Table note"/>
+          <p:cNvSpPr txBox="1"/>
+          <p:nvPr/>
+        </p:nvSpPr>
+        <p:spPr>
+          <a:xfrm>
+            <a:off x="838200" y="5299392"/>
+            <a:ext cx="10515600" cy="301752"/>
+          </a:xfrm>
+          <a:prstGeom prst="rect">
+            <a:avLst/>
+          </a:prstGeom>
+          <a:noFill/>
+        </p:spPr>
+        <p:txBody>
+          <a:bodyPr wrap="none">
+            <a:spAutoFit/>
+          </a:bodyPr>
+          <a:lstStyle/>
+          <a:p>
+            <a:r>
+              <a:rPr sz="1100" i="1" dirty="0"/>
+              <a:t>Train and test: number of series in the official splits. FD-A and FD-B: windows in the processed TF-C data.</a:t>
+            </a:r>
+          </a:p>
+        </p:txBody>
+      </p:sp>
     </p:spTree>
     <p:extLst>
       <p:ext uri="{BB962C8B-B14F-4D97-AF65-F5344CB8AC3E}">
@@ -11397,8 +13012,26 @@
           <a:lstStyle/>
           <a:p>
             <a:r>
+              <a:rPr lang="da-DK" sz="2000" b="1" dirty="0"/>
+              <a:t>Scaling: </a:t>
+            </a:r>
+            <a:r>
+              <a:rPr lang="da-DK" sz="2000" dirty="0"/>
+              <a:t>z-scaling, fitted on training data,</a:t>
+            </a:r>
+            <a:br>
+              <a:rPr lang="da-DK" sz="2000" dirty="0"/>
+            </a:br>
+            <a:r>
+              <a:rPr lang="da-DK" sz="2000" dirty="0"/>
+              <a:t>per channels and representations </a:t>
+            </a:r>
+            <a:endParaRPr lang="da-DK" sz="1600" b="1" dirty="0"/>
+          </a:p>
+          <a:p>
+            <a:r>
               <a:rPr lang="da-DK" sz="2000" b="1" dirty="0" err="1"/>
-              <a:t>Scaling</a:t>
+              <a:t>Validation</a:t>
             </a:r>
             <a:r>
               <a:rPr lang="da-DK" sz="2000" b="1" dirty="0"/>
@@ -11406,95 +13039,40 @@
             </a:r>
             <a:r>
               <a:rPr lang="da-DK" sz="2000" dirty="0"/>
-              <a:t>z-</a:t>
+              <a:t>5-fold </a:t>
             </a:r>
             <a:r>
               <a:rPr lang="da-DK" sz="2000" dirty="0" err="1"/>
-              <a:t>scaling</a:t>
+              <a:t>stratified</a:t>
             </a:r>
             <a:r>
               <a:rPr lang="da-DK" sz="2000" dirty="0"/>
-              <a:t>, </a:t>
+              <a:t> CV for </a:t>
             </a:r>
             <a:r>
               <a:rPr lang="da-DK" sz="2000" dirty="0" err="1"/>
-              <a:t>fitted</a:t>
+              <a:t>hyperparameter</a:t>
             </a:r>
             <a:r>
               <a:rPr lang="da-DK" sz="2000" dirty="0"/>
-              <a:t> on </a:t>
+              <a:t> tuning (</a:t>
             </a:r>
             <a:r>
               <a:rPr lang="da-DK" sz="2000" dirty="0" err="1"/>
-              <a:t>training</a:t>
+              <a:t>unless</a:t>
             </a:r>
             <a:r>
               <a:rPr lang="da-DK" sz="2000" dirty="0"/>
-              <a:t> data, per </a:t>
+              <a:t> dataset </a:t>
             </a:r>
             <a:r>
               <a:rPr lang="da-DK" sz="2000" dirty="0" err="1"/>
-              <a:t>channels</a:t>
-            </a:r>
-            <a:r>
-              <a:rPr lang="da-DK" sz="2000" dirty="0"/>
-              <a:t> and </a:t>
-            </a:r>
-            <a:r>
-              <a:rPr lang="da-DK" sz="2000" dirty="0" err="1"/>
-              <a:t>representations</a:t>
+              <a:t>doesn’t</a:t>
             </a:r>
             <a:r>
               <a:rPr lang="da-DK" sz="2000" dirty="0"/>
               <a:t> </a:t>
             </a:r>
-            <a:endParaRPr lang="da-DK" sz="1600" b="1" dirty="0"/>
-          </a:p>
-          <a:p>
-            <a:r>
-              <a:rPr lang="da-DK" sz="2000" b="1" dirty="0" err="1"/>
-              <a:t>Validation</a:t>
-            </a:r>
-            <a:r>
-              <a:rPr lang="da-DK" sz="2000" b="1" dirty="0"/>
-              <a:t>: </a:t>
-            </a:r>
-            <a:r>
-              <a:rPr lang="da-DK" sz="2000" dirty="0"/>
-              <a:t>5-fold </a:t>
-            </a:r>
-            <a:r>
-              <a:rPr lang="da-DK" sz="2000" dirty="0" err="1"/>
-              <a:t>stratified</a:t>
-            </a:r>
-            <a:r>
-              <a:rPr lang="da-DK" sz="2000" dirty="0"/>
-              <a:t> CV for </a:t>
-            </a:r>
-            <a:r>
-              <a:rPr lang="da-DK" sz="2000" dirty="0" err="1"/>
-              <a:t>hyperparameter</a:t>
-            </a:r>
-            <a:r>
-              <a:rPr lang="da-DK" sz="2000" dirty="0"/>
-              <a:t> tuning (</a:t>
-            </a:r>
-            <a:r>
-              <a:rPr lang="da-DK" sz="2000" dirty="0" err="1"/>
-              <a:t>unless</a:t>
-            </a:r>
-            <a:r>
-              <a:rPr lang="da-DK" sz="2000" dirty="0"/>
-              <a:t> dataset </a:t>
-            </a:r>
-            <a:r>
-              <a:rPr lang="da-DK" sz="2000" dirty="0" err="1"/>
-              <a:t>doesn’t</a:t>
-            </a:r>
-            <a:r>
-              <a:rPr lang="da-DK" sz="2000" dirty="0"/>
-              <a:t> </a:t>
-            </a:r>
             <a:r>
               <a:rPr lang="da-DK" sz="2000" dirty="0" err="1"/>
               <a:t>allow</a:t>
@@ -11596,28 +13174,12 @@
           </a:p>
           <a:p>
             <a:r>
-              <a:rPr lang="da-DK" sz="2200" b="1" dirty="0" err="1"/>
-              <a:t>Metrics</a:t>
-            </a:r>
-            <a:r>
               <a:rPr lang="da-DK" sz="2200" b="1" dirty="0"/>
-              <a:t>: </a:t>
-            </a:r>
-            <a:r>
-              <a:rPr lang="da-DK" sz="2200" dirty="0" err="1"/>
-              <a:t>mean</a:t>
+              <a:t>Metrics: </a:t>
             </a:r>
             <a:r>
               <a:rPr lang="da-DK" sz="2200" dirty="0"/>
-              <a:t> and </a:t>
-            </a:r>
-            <a:r>
-              <a:rPr lang="da-DK" sz="2200" dirty="0" err="1"/>
-              <a:t>std</a:t>
-            </a:r>
-            <a:r>
-              <a:rPr lang="da-DK" sz="2200" dirty="0"/>
-              <a:t> of </a:t>
+              <a:t>mean and std. of </a:t>
             </a:r>
             <a:r>
               <a:rPr lang="da-DK" sz="2200" dirty="0" err="1"/>
@@ -11788,15 +13350,14 @@
           <a:p>
             <a:r>
               <a:rPr lang="da-DK" dirty="0"/>
-              <a:t>Part B – </a:t>
-            </a:r>
-            <a:r>
-              <a:rPr lang="da-DK" dirty="0" err="1"/>
-              <a:t>raw</a:t>
-            </a:r>
-            <a:r>
+              <a:t>Part B</a:t>
+            </a:r>
+            <a:br>
               <a:rPr lang="da-DK" dirty="0"/>
-              <a:t> signal baselines</a:t>
+            </a:br>
+            <a:r>
+              <a:rPr lang="da-DK" sz="2000" dirty="0"/>
+              <a:t>Initial tests on raw data</a:t>
             </a:r>
           </a:p>
         </p:txBody>
@@ -13541,15 +15102,14 @@
           <a:p>
             <a:r>
               <a:rPr lang="da-DK" dirty="0"/>
-              <a:t>Part C – initial test of T-</a:t>
-            </a:r>
-            <a:r>
-              <a:rPr lang="da-DK" dirty="0" err="1"/>
-              <a:t>Loss</a:t>
-            </a:r>
-            <a:r>
+              <a:t>Part C</a:t>
+            </a:r>
+            <a:br>
               <a:rPr lang="da-DK" dirty="0"/>
-              <a:t> and TS2Vec</a:t>
+            </a:br>
+            <a:r>
+              <a:rPr lang="da-DK" sz="2000" dirty="0"/>
+              <a:t>Representations from T-Loss and TS2Vec</a:t>
             </a:r>
           </a:p>
         </p:txBody>

</xml_diff>